<commit_message>
Replace crowded top nav with left drawer menu
Slim header (menu button, brand, testnet chip, language toggle). New slide-in left drawer with grouped navigation: page sections with IntersectionObserver scroll-spy highlighting, all apps, and resources. Esc/overlay/link-click close, aria-expanded, reduced-motion respected. Supersedes the Apps hover mega-menu and the old mobile burger dropdown.

Co-Authored-By: Claude Fable 5 <noreply@anthropic.com>
</commit_message>
<xml_diff>
--- a/docs/QWATT-stellar-community.pptx
+++ b/docs/QWATT-stellar-community.pptx
@@ -4,6 +4,9 @@
   <p:sldMasterIdLst>
     <p:sldMasterId id="2147483648" r:id="rId1"/>
   </p:sldMasterIdLst>
+  <p:notesMasterIdLst>
+    <p:notesMasterId r:id="rId16"/>
+  </p:notesMasterIdLst>
   <p:sldIdLst>
     <p:sldId id="256" r:id="rId2"/>
     <p:sldId id="257" r:id="rId3"/>
@@ -20,9 +23,6 @@
     <p:sldId id="268" r:id="rId14"/>
     <p:sldId id="269" r:id="rId15"/>
   </p:sldIdLst>
-  <p:notesMasterIdLst>
-    <p:notesMasterId r:id="rId16"/>
-  </p:notesMasterIdLst>
   <p:sldSz cx="12192000" cy="6858000"/>
   <p:notesSz cx="6858000" cy="12192000"/>
   <p:defaultTextStyle>
@@ -117,6 +117,11 @@
       </a:defRPr>
     </a:lvl9pPr>
   </p:defaultTextStyle>
+  <p:extLst>
+    <p:ext uri="{EFAFB233-063F-42B5-8137-9DF3F51BA10A}">
+      <p15:sldGuideLst xmlns:p15="http://schemas.microsoft.com/office/powerpoint/2012/main"/>
+    </p:ext>
+  </p:extLst>
 </p:presentation>
 </file>
 
@@ -142,234 +147,10 @@
           <a:chExt cx="0" cy="0"/>
         </a:xfrm>
       </p:grpSpPr>
-      <p:sp>
-        <p:nvSpPr>
-          <p:cNvPr id="2" name="Header Placeholder 1"/>
-          <p:cNvSpPr>
-            <a:spLocks noGrp="1"/>
-          </p:cNvSpPr>
-          <p:nvPr>
-            <p:ph type="hdr" sz="quarter"/>
-          </p:nvPr>
-        </p:nvSpPr>
-        <p:spPr>
-          <a:xfrm>
-            <a:off x="0" y="0"/>
-            <a:ext cx="2971800" cy="458788"/>
-          </a:xfrm>
-          <a:prstGeom prst="rect">
-            <a:avLst/>
-          </a:prstGeom>
-        </p:spPr>
-        <p:txBody>
-          <a:bodyPr vert="horz" lIns="91440" tIns="45720" rIns="91440" bIns="45720" rtlCol="0"/>
-          <a:lstStyle>
-            <a:lvl1pPr algn="l">
-              <a:defRPr sz="1200"/>
-            </a:lvl1pPr>
-          </a:lstStyle>
-          <a:p>
-            <a:endParaRPr lang="en-US"/>
-          </a:p>
-        </p:txBody>
-      </p:sp>
-      <p:sp>
-        <p:nvSpPr>
-          <p:cNvPr id="3" name="Date Placeholder 2"/>
-          <p:cNvSpPr>
-            <a:spLocks noGrp="1"/>
-          </p:cNvSpPr>
-          <p:nvPr>
-            <p:ph type="dt" idx="1"/>
-          </p:nvPr>
-        </p:nvSpPr>
-        <p:spPr>
-          <a:xfrm>
-            <a:off x="3884613" y="0"/>
-            <a:ext cx="2971800" cy="458788"/>
-          </a:xfrm>
-          <a:prstGeom prst="rect">
-            <a:avLst/>
-          </a:prstGeom>
-        </p:spPr>
-        <p:txBody>
-          <a:bodyPr vert="horz" lIns="91440" tIns="45720" rIns="91440" bIns="45720" rtlCol="0"/>
-          <a:lstStyle>
-            <a:lvl1pPr algn="r">
-              <a:defRPr sz="1200"/>
-            </a:lvl1pPr>
-          </a:lstStyle>
-          <a:p>
-            <a:fld id="{5282F153-3F37-0F45-9E97-73ACFA13230C}" type="datetimeFigureOut">
-              <a:rPr lang="en-US"/>
-              <a:t>7/23/19</a:t>
-            </a:fld>
-            <a:endParaRPr lang="en-US"/>
-          </a:p>
-        </p:txBody>
-      </p:sp>
-      <p:sp>
-        <p:nvSpPr>
-          <p:cNvPr id="4" name="Slide Image Placeholder 3"/>
-          <p:cNvSpPr>
-            <a:spLocks noGrp="1" noRot="1" noChangeAspect="1"/>
-          </p:cNvSpPr>
-          <p:nvPr>
-            <p:ph type="sldImg" idx="2"/>
-          </p:nvPr>
-        </p:nvSpPr>
-        <p:spPr>
-          <a:xfrm>
-            <a:off x="685800" y="1143000"/>
-            <a:ext cx="5486400" cy="3086100"/>
-          </a:xfrm>
-          <a:prstGeom prst="rect">
-            <a:avLst/>
-          </a:prstGeom>
-          <a:noFill/>
-          <a:ln w="12700">
-            <a:solidFill>
-              <a:prstClr val="black"/>
-            </a:solidFill>
-          </a:ln>
-        </p:spPr>
-        <p:txBody>
-          <a:bodyPr vert="horz" lIns="91440" tIns="45720" rIns="91440" bIns="45720" rtlCol="0" anchor="ctr"/>
-          <a:lstStyle/>
-          <a:p>
-            <a:endParaRPr lang="en-US"/>
-          </a:p>
-        </p:txBody>
-      </p:sp>
-      <p:sp>
-        <p:nvSpPr>
-          <p:cNvPr id="5" name="Notes Placeholder 4"/>
-          <p:cNvSpPr>
-            <a:spLocks noGrp="1"/>
-          </p:cNvSpPr>
-          <p:nvPr>
-            <p:ph type="body" sz="quarter" idx="3"/>
-          </p:nvPr>
-        </p:nvSpPr>
-        <p:spPr>
-          <a:xfrm>
-            <a:off x="685800" y="4400550"/>
-            <a:ext cx="5486400" cy="3600450"/>
-          </a:xfrm>
-          <a:prstGeom prst="rect">
-            <a:avLst/>
-          </a:prstGeom>
-        </p:spPr>
-        <p:txBody>
-          <a:bodyPr vert="horz" lIns="91440" tIns="45720" rIns="91440" bIns="45720" rtlCol="0"/>
-          <a:lstStyle/>
-          <a:p>
-            <a:pPr lvl="0"/>
-            <a:r>
-              <a:rPr lang="en-US"/>
-              <a:t>Click to edit Master text styles</a:t>
-            </a:r>
-          </a:p>
-          <a:p>
-            <a:pPr lvl="1"/>
-            <a:r>
-              <a:rPr lang="en-US"/>
-              <a:t>Second level</a:t>
-            </a:r>
-          </a:p>
-          <a:p>
-            <a:pPr lvl="2"/>
-            <a:r>
-              <a:rPr lang="en-US"/>
-              <a:t>Third level</a:t>
-            </a:r>
-          </a:p>
-          <a:p>
-            <a:pPr lvl="3"/>
-            <a:r>
-              <a:rPr lang="en-US"/>
-              <a:t>Fourth level</a:t>
-            </a:r>
-          </a:p>
-          <a:p>
-            <a:pPr lvl="4"/>
-            <a:r>
-              <a:rPr lang="en-US"/>
-              <a:t>Fifth level</a:t>
-            </a:r>
-          </a:p>
-        </p:txBody>
-      </p:sp>
-      <p:sp>
-        <p:nvSpPr>
-          <p:cNvPr id="6" name="Footer Placeholder 5"/>
-          <p:cNvSpPr>
-            <a:spLocks noGrp="1"/>
-          </p:cNvSpPr>
-          <p:nvPr>
-            <p:ph type="ftr" sz="quarter" idx="4"/>
-          </p:nvPr>
-        </p:nvSpPr>
-        <p:spPr>
-          <a:xfrm>
-            <a:off x="0" y="8685213"/>
-            <a:ext cx="2971800" cy="458787"/>
-          </a:xfrm>
-          <a:prstGeom prst="rect">
-            <a:avLst/>
-          </a:prstGeom>
-        </p:spPr>
-        <p:txBody>
-          <a:bodyPr vert="horz" lIns="91440" tIns="45720" rIns="91440" bIns="45720" rtlCol="0" anchor="b"/>
-          <a:lstStyle>
-            <a:lvl1pPr algn="l">
-              <a:defRPr sz="1200"/>
-            </a:lvl1pPr>
-          </a:lstStyle>
-          <a:p>
-            <a:endParaRPr lang="en-US"/>
-          </a:p>
-        </p:txBody>
-      </p:sp>
-      <p:sp>
-        <p:nvSpPr>
-          <p:cNvPr id="7" name="Slide Number Placeholder 6"/>
-          <p:cNvSpPr>
-            <a:spLocks noGrp="1"/>
-          </p:cNvSpPr>
-          <p:nvPr>
-            <p:ph type="sldNum" sz="quarter" idx="5"/>
-          </p:nvPr>
-        </p:nvSpPr>
-        <p:spPr>
-          <a:xfrm>
-            <a:off x="3884613" y="8685213"/>
-            <a:ext cx="2971800" cy="458787"/>
-          </a:xfrm>
-          <a:prstGeom prst="rect">
-            <a:avLst/>
-          </a:prstGeom>
-        </p:spPr>
-        <p:txBody>
-          <a:bodyPr vert="horz" lIns="91440" tIns="45720" rIns="91440" bIns="45720" rtlCol="0" anchor="b"/>
-          <a:lstStyle>
-            <a:lvl1pPr algn="r">
-              <a:defRPr sz="1200"/>
-            </a:lvl1pPr>
-          </a:lstStyle>
-          <a:p>
-            <a:fld id="{CE5E9CC1-C706-0F49-92D6-E571CC5EEA8F}" type="slidenum">
-              <a:rPr lang="en-US"/>
-              <a:t>‹#›</a:t>
-            </a:fld>
-            <a:endParaRPr lang="en-US"/>
-          </a:p>
-        </p:txBody>
-      </p:sp>
     </p:spTree>
     <p:extLst>
       <p:ext uri="{BB962C8B-B14F-4D97-AF65-F5344CB8AC3E}">
-        <p14:creationId xmlns:p14="http://schemas.microsoft.com/office/powerpoint/2010/main" val="1024086991"/>
+        <p14:creationId xmlns:p14="http://schemas.microsoft.com/office/powerpoint/2010/main" val="83199186"/>
       </p:ext>
     </p:extLst>
   </p:cSld>
@@ -517,7 +298,6 @@
               <a:rPr lang="en-US" dirty="0"/>
               <a:t>QWATT started at the Stellar x AI Studio Build Challenge and became a working protocol in two weeks. This deck: what exists, how it is architected, and the specific help we are asking from the Stellar community.</a:t>
             </a:r>
-            <a:endParaRPr lang="en-US" dirty="0"/>
           </a:p>
         </p:txBody>
       </p:sp>
@@ -601,10 +381,6 @@
           <a:bodyPr/>
           <a:lstStyle/>
           <a:p>
-            <a:r>
-              <a:rPr lang="en-US" dirty="0"/>
-              <a:t/>
-            </a:r>
             <a:endParaRPr lang="en-US" dirty="0"/>
           </a:p>
         </p:txBody>
@@ -689,10 +465,6 @@
           <a:bodyPr/>
           <a:lstStyle/>
           <a:p>
-            <a:r>
-              <a:rPr lang="en-US" dirty="0"/>
-              <a:t/>
-            </a:r>
             <a:endParaRPr lang="en-US" dirty="0"/>
           </a:p>
         </p:txBody>
@@ -777,10 +549,6 @@
           <a:bodyPr/>
           <a:lstStyle/>
           <a:p>
-            <a:r>
-              <a:rPr lang="en-US" dirty="0"/>
-              <a:t/>
-            </a:r>
             <a:endParaRPr lang="en-US" dirty="0"/>
           </a:p>
         </p:txBody>
@@ -865,10 +633,6 @@
           <a:bodyPr/>
           <a:lstStyle/>
           <a:p>
-            <a:r>
-              <a:rPr lang="en-US" dirty="0"/>
-              <a:t/>
-            </a:r>
             <a:endParaRPr lang="en-US" dirty="0"/>
           </a:p>
         </p:txBody>
@@ -953,10 +717,6 @@
           <a:bodyPr/>
           <a:lstStyle/>
           <a:p>
-            <a:r>
-              <a:rPr lang="en-US" dirty="0"/>
-              <a:t/>
-            </a:r>
             <a:endParaRPr lang="en-US" dirty="0"/>
           </a:p>
         </p:txBody>
@@ -1041,10 +801,6 @@
           <a:bodyPr/>
           <a:lstStyle/>
           <a:p>
-            <a:r>
-              <a:rPr lang="en-US" dirty="0"/>
-              <a:t/>
-            </a:r>
             <a:endParaRPr lang="en-US" dirty="0"/>
           </a:p>
         </p:txBody>
@@ -1129,10 +885,6 @@
           <a:bodyPr/>
           <a:lstStyle/>
           <a:p>
-            <a:r>
-              <a:rPr lang="en-US" dirty="0"/>
-              <a:t/>
-            </a:r>
             <a:endParaRPr lang="en-US" dirty="0"/>
           </a:p>
         </p:txBody>
@@ -1217,10 +969,6 @@
           <a:bodyPr/>
           <a:lstStyle/>
           <a:p>
-            <a:r>
-              <a:rPr lang="en-US" dirty="0"/>
-              <a:t/>
-            </a:r>
             <a:endParaRPr lang="en-US" dirty="0"/>
           </a:p>
         </p:txBody>
@@ -1309,7 +1057,6 @@
               <a:rPr lang="en-US" dirty="0"/>
               <a:t>Each layer only trusts evidence from the layer below, and everything that reaches the chain is public. The oracle is a trusted component: QWATT is auditable and verifiable, not trustless - reducing that trust is the technical roadmap.</a:t>
             </a:r>
-            <a:endParaRPr lang="en-US" dirty="0"/>
           </a:p>
         </p:txBody>
       </p:sp>
@@ -1393,10 +1140,6 @@
           <a:bodyPr/>
           <a:lstStyle/>
           <a:p>
-            <a:r>
-              <a:rPr lang="en-US" dirty="0"/>
-              <a:t/>
-            </a:r>
             <a:endParaRPr lang="en-US" dirty="0"/>
           </a:p>
         </p:txBody>
@@ -1481,10 +1224,6 @@
           <a:bodyPr/>
           <a:lstStyle/>
           <a:p>
-            <a:r>
-              <a:rPr lang="en-US" dirty="0"/>
-              <a:t/>
-            </a:r>
             <a:endParaRPr lang="en-US" dirty="0"/>
           </a:p>
         </p:txBody>
@@ -1569,10 +1308,6 @@
           <a:bodyPr/>
           <a:lstStyle/>
           <a:p>
-            <a:r>
-              <a:rPr lang="en-US" dirty="0"/>
-              <a:t/>
-            </a:r>
             <a:endParaRPr lang="en-US" dirty="0"/>
           </a:p>
         </p:txBody>
@@ -1657,10 +1392,6 @@
           <a:bodyPr/>
           <a:lstStyle/>
           <a:p>
-            <a:r>
-              <a:rPr lang="en-US" dirty="0"/>
-              <a:t/>
-            </a:r>
             <a:endParaRPr lang="en-US" dirty="0"/>
           </a:p>
         </p:txBody>
@@ -1734,6 +1465,11 @@
 <file path=ppt/slideMasters/slideMaster1.xml><?xml version="1.0" encoding="utf-8"?>
 <p:sldMaster xmlns:a="http://schemas.openxmlformats.org/drawingml/2006/main" xmlns:r="http://schemas.openxmlformats.org/officeDocument/2006/relationships" xmlns:p="http://schemas.openxmlformats.org/presentationml/2006/main">
   <p:cSld>
+    <p:bg>
+      <p:bgRef idx="1001">
+        <a:schemeClr val="bg1"/>
+      </p:bgRef>
+    </p:bg>
     <p:spTree>
       <p:nvGrpSpPr>
         <p:cNvPr id="1" name=""/>
@@ -2016,6 +1752,7 @@
         <a:solidFill>
           <a:srgbClr val="16100A"/>
         </a:solidFill>
+        <a:effectLst/>
       </p:bgPr>
     </p:bg>
     <p:spTree>
@@ -2040,7 +1777,7 @@
         </p:nvSpPr>
         <p:spPr>
           <a:xfrm>
-            <a:off x="4855464" y="1417320"/>
+            <a:off x="3719391" y="2217420"/>
             <a:ext cx="731520" cy="731520"/>
           </a:xfrm>
           <a:prstGeom prst="rect">
@@ -2053,7 +1790,7 @@
           <a:bodyPr wrap="square" lIns="0" tIns="0" rIns="0" bIns="0" rtlCol="0" anchor="ctr"/>
           <a:lstStyle/>
           <a:p>
-            <a:pPr algn="ctr" indent="0" marL="0">
+            <a:pPr marL="0" indent="0" algn="ctr">
               <a:buNone/>
             </a:pPr>
             <a:r>
@@ -2089,7 +1826,7 @@
           <a:bodyPr wrap="square" lIns="0" tIns="0" rIns="0" bIns="0" rtlCol="0" anchor="ctr"/>
           <a:lstStyle/>
           <a:p>
-            <a:pPr algn="ctr" indent="0" marL="0">
+            <a:pPr marL="0" indent="0" algn="ctr">
               <a:buNone/>
             </a:pPr>
             <a:r>
@@ -2128,7 +1865,7 @@
           <a:bodyPr wrap="square" lIns="0" tIns="0" rIns="0" bIns="0" rtlCol="0" anchor="ctr"/>
           <a:lstStyle/>
           <a:p>
-            <a:pPr algn="ctr" indent="0" marL="0">
+            <a:pPr marL="0" indent="0" algn="ctr">
               <a:buNone/>
             </a:pPr>
             <a:r>
@@ -2167,7 +1904,7 @@
           <a:bodyPr wrap="square" lIns="0" tIns="0" rIns="0" bIns="0" rtlCol="0" anchor="ctr"/>
           <a:lstStyle/>
           <a:p>
-            <a:pPr algn="ctr" indent="0" marL="0">
+            <a:pPr marL="0" indent="0" algn="ctr">
               <a:buNone/>
             </a:pPr>
             <a:r>
@@ -2233,7 +1970,7 @@
           <a:bodyPr wrap="square" lIns="0" tIns="0" rIns="0" bIns="0" rtlCol="0" anchor="ctr"/>
           <a:lstStyle/>
           <a:p>
-            <a:pPr algn="ctr" indent="0" marL="0">
+            <a:pPr marL="0" indent="0" algn="ctr">
               <a:buNone/>
             </a:pPr>
             <a:r>
@@ -2272,7 +2009,7 @@
           <a:bodyPr wrap="square" lIns="0" tIns="0" rIns="0" bIns="0" rtlCol="0" anchor="ctr"/>
           <a:lstStyle/>
           <a:p>
-            <a:pPr algn="ctr" indent="0" marL="0">
+            <a:pPr marL="0" indent="0" algn="ctr">
               <a:buNone/>
             </a:pPr>
             <a:r>
@@ -2306,6 +2043,7 @@
         <a:solidFill>
           <a:srgbClr val="16100A"/>
         </a:solidFill>
+        <a:effectLst/>
       </p:bgPr>
     </p:bg>
     <p:spTree>
@@ -2343,7 +2081,7 @@
           <a:bodyPr wrap="square" lIns="0" tIns="0" rIns="0" bIns="0" rtlCol="0" anchor="ctr"/>
           <a:lstStyle/>
           <a:p>
-            <a:pPr indent="0" marL="0">
+            <a:pPr marL="0" indent="0">
               <a:buNone/>
             </a:pPr>
             <a:r>
@@ -2382,7 +2120,7 @@
           <a:bodyPr wrap="square" lIns="0" tIns="0" rIns="0" bIns="0" rtlCol="0" anchor="ctr"/>
           <a:lstStyle/>
           <a:p>
-            <a:pPr algn="r" indent="0" marL="0">
+            <a:pPr marL="0" indent="0" algn="r">
               <a:buNone/>
             </a:pPr>
             <a:r>
@@ -2421,11 +2159,11 @@
           <a:bodyPr wrap="square" lIns="0" tIns="0" rIns="0" bIns="0" rtlCol="0" anchor="ctr"/>
           <a:lstStyle/>
           <a:p>
-            <a:pPr indent="0" marL="0">
-              <a:buNone/>
-            </a:pPr>
-            <a:r>
-              <a:rPr lang="en-US" sz="1100" b="1" spc="300" kern="0" dirty="0">
+            <a:pPr marL="0" indent="0">
+              <a:buNone/>
+            </a:pPr>
+            <a:r>
+              <a:rPr lang="en-US" sz="1100" b="1" kern="0" spc="300" dirty="0">
                 <a:solidFill>
                   <a:srgbClr val="D08A57"/>
                 </a:solidFill>
@@ -2460,7 +2198,7 @@
           <a:bodyPr wrap="square" lIns="0" tIns="0" rIns="0" bIns="0" rtlCol="0" anchor="ctr"/>
           <a:lstStyle/>
           <a:p>
-            <a:pPr indent="0" marL="0">
+            <a:pPr marL="0" indent="0">
               <a:buNone/>
             </a:pPr>
             <a:r>
@@ -2526,7 +2264,7 @@
           <a:bodyPr wrap="square" lIns="0" tIns="0" rIns="0" bIns="0" rtlCol="0" anchor="ctr"/>
           <a:lstStyle/>
           <a:p>
-            <a:pPr indent="0" marL="0">
+            <a:pPr marL="0" indent="0">
               <a:buNone/>
             </a:pPr>
             <a:r>
@@ -2565,7 +2303,7 @@
           <a:bodyPr wrap="square" lIns="0" tIns="0" rIns="0" bIns="0" rtlCol="0" anchor="ctr"/>
           <a:lstStyle/>
           <a:p>
-            <a:pPr indent="0" marL="0">
+            <a:pPr marL="0" indent="0">
               <a:buNone/>
             </a:pPr>
             <a:r>
@@ -2604,7 +2342,7 @@
           <a:bodyPr wrap="square" lIns="0" tIns="0" rIns="0" bIns="0" rtlCol="0" anchor="ctr"/>
           <a:lstStyle/>
           <a:p>
-            <a:pPr algn="ctr" indent="0" marL="0">
+            <a:pPr marL="0" indent="0" algn="ctr">
               <a:buNone/>
             </a:pPr>
             <a:r>
@@ -2670,7 +2408,7 @@
           <a:bodyPr wrap="square" lIns="0" tIns="0" rIns="0" bIns="0" rtlCol="0" anchor="ctr"/>
           <a:lstStyle/>
           <a:p>
-            <a:pPr indent="0" marL="0">
+            <a:pPr marL="0" indent="0">
               <a:buNone/>
             </a:pPr>
             <a:r>
@@ -2709,7 +2447,7 @@
           <a:bodyPr wrap="square" lIns="0" tIns="0" rIns="0" bIns="0" rtlCol="0" anchor="ctr"/>
           <a:lstStyle/>
           <a:p>
-            <a:pPr indent="0" marL="0">
+            <a:pPr marL="0" indent="0">
               <a:buNone/>
             </a:pPr>
             <a:r>
@@ -2748,7 +2486,7 @@
           <a:bodyPr wrap="square" lIns="0" tIns="0" rIns="0" bIns="0" rtlCol="0" anchor="ctr"/>
           <a:lstStyle/>
           <a:p>
-            <a:pPr algn="ctr" indent="0" marL="0">
+            <a:pPr marL="0" indent="0" algn="ctr">
               <a:buNone/>
             </a:pPr>
             <a:r>
@@ -2814,7 +2552,7 @@
           <a:bodyPr wrap="square" lIns="0" tIns="0" rIns="0" bIns="0" rtlCol="0" anchor="ctr"/>
           <a:lstStyle/>
           <a:p>
-            <a:pPr indent="0" marL="0">
+            <a:pPr marL="0" indent="0">
               <a:buNone/>
             </a:pPr>
             <a:r>
@@ -2853,7 +2591,7 @@
           <a:bodyPr wrap="square" lIns="0" tIns="0" rIns="0" bIns="0" rtlCol="0" anchor="ctr"/>
           <a:lstStyle/>
           <a:p>
-            <a:pPr indent="0" marL="0">
+            <a:pPr marL="0" indent="0">
               <a:buNone/>
             </a:pPr>
             <a:r>
@@ -2892,7 +2630,7 @@
           <a:bodyPr wrap="square" lIns="0" tIns="0" rIns="0" bIns="0" rtlCol="0" anchor="ctr"/>
           <a:lstStyle/>
           <a:p>
-            <a:pPr indent="0" marL="0">
+            <a:pPr marL="0" indent="0">
               <a:buNone/>
             </a:pPr>
             <a:r>
@@ -2931,7 +2669,7 @@
           <a:bodyPr wrap="square" lIns="0" tIns="0" rIns="0" bIns="0" rtlCol="0" anchor="ctr"/>
           <a:lstStyle/>
           <a:p>
-            <a:pPr indent="0" marL="0">
+            <a:pPr marL="0" indent="0">
               <a:buNone/>
             </a:pPr>
             <a:r>
@@ -2970,7 +2708,7 @@
           <a:bodyPr wrap="square" lIns="0" tIns="0" rIns="0" bIns="0" rtlCol="0" anchor="ctr"/>
           <a:lstStyle/>
           <a:p>
-            <a:pPr indent="0" marL="0">
+            <a:pPr marL="0" indent="0">
               <a:buNone/>
             </a:pPr>
             <a:r>
@@ -3004,6 +2742,7 @@
         <a:solidFill>
           <a:srgbClr val="16100A"/>
         </a:solidFill>
+        <a:effectLst/>
       </p:bgPr>
     </p:bg>
     <p:spTree>
@@ -3041,7 +2780,7 @@
           <a:bodyPr wrap="square" lIns="0" tIns="0" rIns="0" bIns="0" rtlCol="0" anchor="ctr"/>
           <a:lstStyle/>
           <a:p>
-            <a:pPr indent="0" marL="0">
+            <a:pPr marL="0" indent="0">
               <a:buNone/>
             </a:pPr>
             <a:r>
@@ -3080,7 +2819,7 @@
           <a:bodyPr wrap="square" lIns="0" tIns="0" rIns="0" bIns="0" rtlCol="0" anchor="ctr"/>
           <a:lstStyle/>
           <a:p>
-            <a:pPr algn="r" indent="0" marL="0">
+            <a:pPr marL="0" indent="0" algn="r">
               <a:buNone/>
             </a:pPr>
             <a:r>
@@ -3119,11 +2858,11 @@
           <a:bodyPr wrap="square" lIns="0" tIns="0" rIns="0" bIns="0" rtlCol="0" anchor="ctr"/>
           <a:lstStyle/>
           <a:p>
-            <a:pPr indent="0" marL="0">
-              <a:buNone/>
-            </a:pPr>
-            <a:r>
-              <a:rPr lang="en-US" sz="1100" b="1" spc="300" kern="0" dirty="0">
+            <a:pPr marL="0" indent="0">
+              <a:buNone/>
+            </a:pPr>
+            <a:r>
+              <a:rPr lang="en-US" sz="1100" b="1" kern="0" spc="300" dirty="0">
                 <a:solidFill>
                   <a:srgbClr val="D08A57"/>
                 </a:solidFill>
@@ -3158,7 +2897,7 @@
           <a:bodyPr wrap="square" lIns="0" tIns="0" rIns="0" bIns="0" rtlCol="0" anchor="ctr"/>
           <a:lstStyle/>
           <a:p>
-            <a:pPr indent="0" marL="0">
+            <a:pPr marL="0" indent="0">
               <a:buNone/>
             </a:pPr>
             <a:r>
@@ -3224,7 +2963,7 @@
           <a:bodyPr wrap="square" lIns="0" tIns="0" rIns="0" bIns="0" rtlCol="0" anchor="ctr"/>
           <a:lstStyle/>
           <a:p>
-            <a:pPr algn="ctr" indent="0" marL="0">
+            <a:pPr marL="0" indent="0" algn="ctr">
               <a:buNone/>
             </a:pPr>
             <a:r>
@@ -3263,7 +3002,7 @@
           <a:bodyPr wrap="square" lIns="0" tIns="0" rIns="0" bIns="0" rtlCol="0" anchor="ctr"/>
           <a:lstStyle/>
           <a:p>
-            <a:pPr algn="ctr" indent="0" marL="0">
+            <a:pPr marL="0" indent="0" algn="ctr">
               <a:buNone/>
             </a:pPr>
             <a:r>
@@ -3329,7 +3068,7 @@
           <a:bodyPr wrap="square" lIns="0" tIns="0" rIns="0" bIns="0" rtlCol="0" anchor="ctr"/>
           <a:lstStyle/>
           <a:p>
-            <a:pPr algn="ctr" indent="0" marL="0">
+            <a:pPr marL="0" indent="0" algn="ctr">
               <a:buNone/>
             </a:pPr>
             <a:r>
@@ -3368,7 +3107,7 @@
           <a:bodyPr wrap="square" lIns="0" tIns="0" rIns="0" bIns="0" rtlCol="0" anchor="ctr"/>
           <a:lstStyle/>
           <a:p>
-            <a:pPr algn="ctr" indent="0" marL="0">
+            <a:pPr marL="0" indent="0" algn="ctr">
               <a:buNone/>
             </a:pPr>
             <a:r>
@@ -3434,7 +3173,7 @@
           <a:bodyPr wrap="square" lIns="0" tIns="0" rIns="0" bIns="0" rtlCol="0" anchor="ctr"/>
           <a:lstStyle/>
           <a:p>
-            <a:pPr algn="ctr" indent="0" marL="0">
+            <a:pPr marL="0" indent="0" algn="ctr">
               <a:buNone/>
             </a:pPr>
             <a:r>
@@ -3473,7 +3212,7 @@
           <a:bodyPr wrap="square" lIns="0" tIns="0" rIns="0" bIns="0" rtlCol="0" anchor="ctr"/>
           <a:lstStyle/>
           <a:p>
-            <a:pPr algn="ctr" indent="0" marL="0">
+            <a:pPr marL="0" indent="0" algn="ctr">
               <a:buNone/>
             </a:pPr>
             <a:r>
@@ -3539,7 +3278,7 @@
           <a:bodyPr wrap="square" lIns="0" tIns="0" rIns="0" bIns="0" rtlCol="0" anchor="ctr"/>
           <a:lstStyle/>
           <a:p>
-            <a:pPr algn="ctr" indent="0" marL="0">
+            <a:pPr marL="0" indent="0" algn="ctr">
               <a:buNone/>
             </a:pPr>
             <a:r>
@@ -3578,7 +3317,7 @@
           <a:bodyPr wrap="square" lIns="0" tIns="0" rIns="0" bIns="0" rtlCol="0" anchor="ctr"/>
           <a:lstStyle/>
           <a:p>
-            <a:pPr algn="ctr" indent="0" marL="0">
+            <a:pPr marL="0" indent="0" algn="ctr">
               <a:buNone/>
             </a:pPr>
             <a:r>
@@ -3715,6 +3454,7 @@
         <a:solidFill>
           <a:srgbClr val="16100A"/>
         </a:solidFill>
+        <a:effectLst/>
       </p:bgPr>
     </p:bg>
     <p:spTree>
@@ -3752,7 +3492,7 @@
           <a:bodyPr wrap="square" lIns="0" tIns="0" rIns="0" bIns="0" rtlCol="0" anchor="ctr"/>
           <a:lstStyle/>
           <a:p>
-            <a:pPr indent="0" marL="0">
+            <a:pPr marL="0" indent="0">
               <a:buNone/>
             </a:pPr>
             <a:r>
@@ -3791,7 +3531,7 @@
           <a:bodyPr wrap="square" lIns="0" tIns="0" rIns="0" bIns="0" rtlCol="0" anchor="ctr"/>
           <a:lstStyle/>
           <a:p>
-            <a:pPr algn="r" indent="0" marL="0">
+            <a:pPr marL="0" indent="0" algn="r">
               <a:buNone/>
             </a:pPr>
             <a:r>
@@ -3830,11 +3570,11 @@
           <a:bodyPr wrap="square" lIns="0" tIns="0" rIns="0" bIns="0" rtlCol="0" anchor="ctr"/>
           <a:lstStyle/>
           <a:p>
-            <a:pPr indent="0" marL="0">
-              <a:buNone/>
-            </a:pPr>
-            <a:r>
-              <a:rPr lang="en-US" sz="1100" b="1" spc="300" kern="0" dirty="0">
+            <a:pPr marL="0" indent="0">
+              <a:buNone/>
+            </a:pPr>
+            <a:r>
+              <a:rPr lang="en-US" sz="1100" b="1" kern="0" spc="300" dirty="0">
                 <a:solidFill>
                   <a:srgbClr val="D08A57"/>
                 </a:solidFill>
@@ -3869,7 +3609,7 @@
           <a:bodyPr wrap="square" lIns="0" tIns="0" rIns="0" bIns="0" rtlCol="0" anchor="ctr"/>
           <a:lstStyle/>
           <a:p>
-            <a:pPr indent="0" marL="0">
+            <a:pPr marL="0" indent="0">
               <a:buNone/>
             </a:pPr>
             <a:r>
@@ -3935,7 +3675,7 @@
           <a:bodyPr wrap="square" lIns="0" tIns="0" rIns="0" bIns="0" rtlCol="0" anchor="ctr"/>
           <a:lstStyle/>
           <a:p>
-            <a:pPr indent="0" marL="0">
+            <a:pPr marL="0" indent="0">
               <a:buNone/>
             </a:pPr>
             <a:r>
@@ -4001,7 +3741,7 @@
           <a:bodyPr wrap="square" lIns="0" tIns="0" rIns="0" bIns="0" rtlCol="0" anchor="ctr"/>
           <a:lstStyle/>
           <a:p>
-            <a:pPr algn="ctr" indent="0" marL="0">
+            <a:pPr marL="0" indent="0" algn="ctr">
               <a:buNone/>
             </a:pPr>
             <a:r>
@@ -4040,7 +3780,7 @@
           <a:bodyPr wrap="square" lIns="0" tIns="0" rIns="0" bIns="0" rtlCol="0" anchor="ctr"/>
           <a:lstStyle/>
           <a:p>
-            <a:pPr indent="0" marL="0">
+            <a:pPr marL="0" indent="0">
               <a:buNone/>
             </a:pPr>
             <a:r>
@@ -4106,7 +3846,7 @@
           <a:bodyPr wrap="square" lIns="0" tIns="0" rIns="0" bIns="0" rtlCol="0" anchor="ctr"/>
           <a:lstStyle/>
           <a:p>
-            <a:pPr indent="0" marL="0">
+            <a:pPr marL="0" indent="0">
               <a:buNone/>
             </a:pPr>
             <a:r>
@@ -4172,7 +3912,7 @@
           <a:bodyPr wrap="square" lIns="0" tIns="0" rIns="0" bIns="0" rtlCol="0" anchor="ctr"/>
           <a:lstStyle/>
           <a:p>
-            <a:pPr algn="ctr" indent="0" marL="0">
+            <a:pPr marL="0" indent="0" algn="ctr">
               <a:buNone/>
             </a:pPr>
             <a:r>
@@ -4211,7 +3951,7 @@
           <a:bodyPr wrap="square" lIns="0" tIns="0" rIns="0" bIns="0" rtlCol="0" anchor="ctr"/>
           <a:lstStyle/>
           <a:p>
-            <a:pPr indent="0" marL="0">
+            <a:pPr marL="0" indent="0">
               <a:buNone/>
             </a:pPr>
             <a:r>
@@ -4277,7 +4017,7 @@
           <a:bodyPr wrap="square" lIns="0" tIns="0" rIns="0" bIns="0" rtlCol="0" anchor="ctr"/>
           <a:lstStyle/>
           <a:p>
-            <a:pPr indent="0" marL="0">
+            <a:pPr marL="0" indent="0">
               <a:buNone/>
             </a:pPr>
             <a:r>
@@ -4343,7 +4083,7 @@
           <a:bodyPr wrap="square" lIns="0" tIns="0" rIns="0" bIns="0" rtlCol="0" anchor="ctr"/>
           <a:lstStyle/>
           <a:p>
-            <a:pPr algn="ctr" indent="0" marL="0">
+            <a:pPr marL="0" indent="0" algn="ctr">
               <a:buNone/>
             </a:pPr>
             <a:r>
@@ -4382,7 +4122,7 @@
           <a:bodyPr wrap="square" lIns="0" tIns="0" rIns="0" bIns="0" rtlCol="0" anchor="ctr"/>
           <a:lstStyle/>
           <a:p>
-            <a:pPr indent="0" marL="0">
+            <a:pPr marL="0" indent="0">
               <a:buNone/>
             </a:pPr>
             <a:r>
@@ -4448,7 +4188,7 @@
           <a:bodyPr wrap="square" lIns="0" tIns="0" rIns="0" bIns="0" rtlCol="0" anchor="ctr"/>
           <a:lstStyle/>
           <a:p>
-            <a:pPr indent="0" marL="0">
+            <a:pPr marL="0" indent="0">
               <a:buNone/>
             </a:pPr>
             <a:r>
@@ -4514,7 +4254,7 @@
           <a:bodyPr wrap="square" lIns="0" tIns="0" rIns="0" bIns="0" rtlCol="0" anchor="ctr"/>
           <a:lstStyle/>
           <a:p>
-            <a:pPr algn="ctr" indent="0" marL="0">
+            <a:pPr marL="0" indent="0" algn="ctr">
               <a:buNone/>
             </a:pPr>
             <a:r>
@@ -4553,7 +4293,7 @@
           <a:bodyPr wrap="square" lIns="0" tIns="0" rIns="0" bIns="0" rtlCol="0" anchor="ctr"/>
           <a:lstStyle/>
           <a:p>
-            <a:pPr indent="0" marL="0">
+            <a:pPr marL="0" indent="0">
               <a:buNone/>
             </a:pPr>
             <a:r>
@@ -4592,7 +4332,7 @@
           <a:bodyPr wrap="square" lIns="0" tIns="0" rIns="0" bIns="0" rtlCol="0" anchor="ctr"/>
           <a:lstStyle/>
           <a:p>
-            <a:pPr algn="ctr" indent="0" marL="0">
+            <a:pPr marL="0" indent="0" algn="ctr">
               <a:buNone/>
             </a:pPr>
             <a:r>
@@ -4626,6 +4366,7 @@
         <a:solidFill>
           <a:srgbClr val="16100A"/>
         </a:solidFill>
+        <a:effectLst/>
       </p:bgPr>
     </p:bg>
     <p:spTree>
@@ -4663,7 +4404,7 @@
           <a:bodyPr wrap="square" lIns="0" tIns="0" rIns="0" bIns="0" rtlCol="0" anchor="ctr"/>
           <a:lstStyle/>
           <a:p>
-            <a:pPr indent="0" marL="0">
+            <a:pPr marL="0" indent="0">
               <a:buNone/>
             </a:pPr>
             <a:r>
@@ -4702,7 +4443,7 @@
           <a:bodyPr wrap="square" lIns="0" tIns="0" rIns="0" bIns="0" rtlCol="0" anchor="ctr"/>
           <a:lstStyle/>
           <a:p>
-            <a:pPr algn="r" indent="0" marL="0">
+            <a:pPr marL="0" indent="0" algn="r">
               <a:buNone/>
             </a:pPr>
             <a:r>
@@ -4741,11 +4482,11 @@
           <a:bodyPr wrap="square" lIns="0" tIns="0" rIns="0" bIns="0" rtlCol="0" anchor="ctr"/>
           <a:lstStyle/>
           <a:p>
-            <a:pPr indent="0" marL="0">
-              <a:buNone/>
-            </a:pPr>
-            <a:r>
-              <a:rPr lang="en-US" sz="1100" b="1" spc="300" kern="0" dirty="0">
+            <a:pPr marL="0" indent="0">
+              <a:buNone/>
+            </a:pPr>
+            <a:r>
+              <a:rPr lang="en-US" sz="1100" b="1" kern="0" spc="300" dirty="0">
                 <a:solidFill>
                   <a:srgbClr val="D08A57"/>
                 </a:solidFill>
@@ -4780,7 +4521,7 @@
           <a:bodyPr wrap="square" lIns="0" tIns="0" rIns="0" bIns="0" rtlCol="0" anchor="ctr"/>
           <a:lstStyle/>
           <a:p>
-            <a:pPr indent="0" marL="0">
+            <a:pPr marL="0" indent="0">
               <a:buNone/>
             </a:pPr>
             <a:r>
@@ -4819,7 +4560,7 @@
           <a:bodyPr wrap="square" lIns="0" tIns="0" rIns="0" bIns="0" rtlCol="0" anchor="ctr"/>
           <a:lstStyle/>
           <a:p>
-            <a:pPr indent="0" marL="0">
+            <a:pPr marL="0" indent="0">
               <a:buNone/>
             </a:pPr>
             <a:r>
@@ -4858,7 +4599,7 @@
           <a:bodyPr wrap="square" lIns="0" tIns="0" rIns="0" bIns="0" rtlCol="0" anchor="t"/>
           <a:lstStyle/>
           <a:p>
-            <a:pPr indent="0" marL="0">
+            <a:pPr marL="0" indent="0">
               <a:buNone/>
             </a:pPr>
             <a:r>
@@ -4897,7 +4638,7 @@
           <a:bodyPr wrap="square" lIns="0" tIns="0" rIns="0" bIns="0" rtlCol="0" anchor="t"/>
           <a:lstStyle/>
           <a:p>
-            <a:pPr indent="0" marL="0">
+            <a:pPr marL="0" indent="0">
               <a:buNone/>
             </a:pPr>
             <a:r>
@@ -4936,7 +4677,7 @@
           <a:bodyPr wrap="square" lIns="0" tIns="0" rIns="0" bIns="0" rtlCol="0" anchor="ctr"/>
           <a:lstStyle/>
           <a:p>
-            <a:pPr indent="0" marL="0">
+            <a:pPr marL="0" indent="0">
               <a:buNone/>
             </a:pPr>
             <a:r>
@@ -4975,7 +4716,7 @@
           <a:bodyPr wrap="square" lIns="0" tIns="0" rIns="0" bIns="0" rtlCol="0" anchor="t"/>
           <a:lstStyle/>
           <a:p>
-            <a:pPr indent="0" marL="0">
+            <a:pPr marL="0" indent="0">
               <a:buNone/>
             </a:pPr>
             <a:r>
@@ -5014,7 +4755,7 @@
           <a:bodyPr wrap="square" lIns="0" tIns="0" rIns="0" bIns="0" rtlCol="0" anchor="t"/>
           <a:lstStyle/>
           <a:p>
-            <a:pPr indent="0" marL="0">
+            <a:pPr marL="0" indent="0">
               <a:buNone/>
             </a:pPr>
             <a:r>
@@ -5053,7 +4794,7 @@
           <a:bodyPr wrap="square" lIns="0" tIns="0" rIns="0" bIns="0" rtlCol="0" anchor="ctr"/>
           <a:lstStyle/>
           <a:p>
-            <a:pPr indent="0" marL="0">
+            <a:pPr marL="0" indent="0">
               <a:buNone/>
             </a:pPr>
             <a:r>
@@ -5092,7 +4833,7 @@
           <a:bodyPr wrap="square" lIns="0" tIns="0" rIns="0" bIns="0" rtlCol="0" anchor="t"/>
           <a:lstStyle/>
           <a:p>
-            <a:pPr indent="0" marL="0">
+            <a:pPr marL="0" indent="0">
               <a:buNone/>
             </a:pPr>
             <a:r>
@@ -5131,7 +4872,7 @@
           <a:bodyPr wrap="square" lIns="0" tIns="0" rIns="0" bIns="0" rtlCol="0" anchor="t"/>
           <a:lstStyle/>
           <a:p>
-            <a:pPr indent="0" marL="0">
+            <a:pPr marL="0" indent="0">
               <a:buNone/>
             </a:pPr>
             <a:r>
@@ -5170,7 +4911,7 @@
           <a:bodyPr wrap="square" lIns="0" tIns="0" rIns="0" bIns="0" rtlCol="0" anchor="ctr"/>
           <a:lstStyle/>
           <a:p>
-            <a:pPr indent="0" marL="0">
+            <a:pPr marL="0" indent="0">
               <a:buNone/>
             </a:pPr>
             <a:r>
@@ -5209,7 +4950,7 @@
           <a:bodyPr wrap="square" lIns="0" tIns="0" rIns="0" bIns="0" rtlCol="0" anchor="t"/>
           <a:lstStyle/>
           <a:p>
-            <a:pPr indent="0" marL="0">
+            <a:pPr marL="0" indent="0">
               <a:buNone/>
             </a:pPr>
             <a:r>
@@ -5248,7 +4989,7 @@
           <a:bodyPr wrap="square" lIns="0" tIns="0" rIns="0" bIns="0" rtlCol="0" anchor="t"/>
           <a:lstStyle/>
           <a:p>
-            <a:pPr indent="0" marL="0">
+            <a:pPr marL="0" indent="0">
               <a:buNone/>
             </a:pPr>
             <a:r>
@@ -5287,7 +5028,7 @@
           <a:bodyPr wrap="square" lIns="0" tIns="0" rIns="0" bIns="0" rtlCol="0" anchor="ctr"/>
           <a:lstStyle/>
           <a:p>
-            <a:pPr indent="0" marL="0">
+            <a:pPr marL="0" indent="0">
               <a:buNone/>
             </a:pPr>
             <a:r>
@@ -5326,7 +5067,7 @@
           <a:bodyPr wrap="square" lIns="0" tIns="0" rIns="0" bIns="0" rtlCol="0" anchor="t"/>
           <a:lstStyle/>
           <a:p>
-            <a:pPr indent="0" marL="0">
+            <a:pPr marL="0" indent="0">
               <a:buNone/>
             </a:pPr>
             <a:r>
@@ -5365,7 +5106,7 @@
           <a:bodyPr wrap="square" lIns="0" tIns="0" rIns="0" bIns="0" rtlCol="0" anchor="t"/>
           <a:lstStyle/>
           <a:p>
-            <a:pPr indent="0" marL="0">
+            <a:pPr marL="0" indent="0">
               <a:buNone/>
             </a:pPr>
             <a:r>
@@ -5399,6 +5140,7 @@
         <a:solidFill>
           <a:srgbClr val="16100A"/>
         </a:solidFill>
+        <a:effectLst/>
       </p:bgPr>
     </p:bg>
     <p:spTree>
@@ -5436,7 +5178,7 @@
           <a:bodyPr wrap="square" lIns="0" tIns="0" rIns="0" bIns="0" rtlCol="0" anchor="ctr"/>
           <a:lstStyle/>
           <a:p>
-            <a:pPr algn="ctr" indent="0" marL="0">
+            <a:pPr marL="0" indent="0" algn="ctr">
               <a:buNone/>
             </a:pPr>
             <a:r>
@@ -5475,7 +5217,7 @@
           <a:bodyPr wrap="square" lIns="0" tIns="0" rIns="0" bIns="0" rtlCol="0" anchor="ctr"/>
           <a:lstStyle/>
           <a:p>
-            <a:pPr algn="ctr" indent="0" marL="0">
+            <a:pPr marL="0" indent="0" algn="ctr">
               <a:buNone/>
             </a:pPr>
             <a:r>
@@ -5514,7 +5256,7 @@
           <a:bodyPr wrap="square" lIns="0" tIns="0" rIns="0" bIns="0" rtlCol="0" anchor="ctr"/>
           <a:lstStyle/>
           <a:p>
-            <a:pPr algn="ctr" indent="0" marL="0">
+            <a:pPr marL="0" indent="0" algn="ctr">
               <a:buNone/>
             </a:pPr>
             <a:r>
@@ -5553,7 +5295,7 @@
           <a:bodyPr wrap="square" lIns="0" tIns="0" rIns="0" bIns="0" rtlCol="0" anchor="ctr"/>
           <a:lstStyle/>
           <a:p>
-            <a:pPr algn="ctr" indent="0" marL="0">
+            <a:pPr marL="0" indent="0" algn="ctr">
               <a:buNone/>
             </a:pPr>
             <a:r>
@@ -5592,7 +5334,7 @@
           <a:bodyPr wrap="square" lIns="0" tIns="0" rIns="0" bIns="0" rtlCol="0" anchor="ctr"/>
           <a:lstStyle/>
           <a:p>
-            <a:pPr algn="ctr" indent="0" marL="0">
+            <a:pPr marL="0" indent="0" algn="ctr">
               <a:buNone/>
             </a:pPr>
             <a:r>
@@ -5626,6 +5368,7 @@
         <a:solidFill>
           <a:srgbClr val="16100A"/>
         </a:solidFill>
+        <a:effectLst/>
       </p:bgPr>
     </p:bg>
     <p:spTree>
@@ -5663,7 +5406,7 @@
           <a:bodyPr wrap="square" lIns="0" tIns="0" rIns="0" bIns="0" rtlCol="0" anchor="ctr"/>
           <a:lstStyle/>
           <a:p>
-            <a:pPr indent="0" marL="0">
+            <a:pPr marL="0" indent="0">
               <a:buNone/>
             </a:pPr>
             <a:r>
@@ -5702,7 +5445,7 @@
           <a:bodyPr wrap="square" lIns="0" tIns="0" rIns="0" bIns="0" rtlCol="0" anchor="ctr"/>
           <a:lstStyle/>
           <a:p>
-            <a:pPr algn="r" indent="0" marL="0">
+            <a:pPr marL="0" indent="0" algn="r">
               <a:buNone/>
             </a:pPr>
             <a:r>
@@ -5741,11 +5484,11 @@
           <a:bodyPr wrap="square" lIns="0" tIns="0" rIns="0" bIns="0" rtlCol="0" anchor="ctr"/>
           <a:lstStyle/>
           <a:p>
-            <a:pPr indent="0" marL="0">
-              <a:buNone/>
-            </a:pPr>
-            <a:r>
-              <a:rPr lang="en-US" sz="1100" b="1" spc="300" kern="0" dirty="0">
+            <a:pPr marL="0" indent="0">
+              <a:buNone/>
+            </a:pPr>
+            <a:r>
+              <a:rPr lang="en-US" sz="1100" b="1" kern="0" spc="300" dirty="0">
                 <a:solidFill>
                   <a:srgbClr val="D08A57"/>
                 </a:solidFill>
@@ -5780,7 +5523,7 @@
           <a:bodyPr wrap="square" lIns="0" tIns="0" rIns="0" bIns="0" rtlCol="0" anchor="ctr"/>
           <a:lstStyle/>
           <a:p>
-            <a:pPr indent="0" marL="0">
+            <a:pPr marL="0" indent="0">
               <a:buNone/>
             </a:pPr>
             <a:r>
@@ -5846,7 +5589,7 @@
           <a:bodyPr wrap="square" lIns="0" tIns="0" rIns="0" bIns="0" rtlCol="0" anchor="ctr"/>
           <a:lstStyle/>
           <a:p>
-            <a:pPr indent="0" marL="0">
+            <a:pPr marL="0" indent="0">
               <a:buNone/>
             </a:pPr>
             <a:r>
@@ -5885,7 +5628,7 @@
           <a:bodyPr wrap="square" lIns="0" tIns="0" rIns="0" bIns="0" rtlCol="0" anchor="ctr"/>
           <a:lstStyle/>
           <a:p>
-            <a:pPr indent="0" marL="0">
+            <a:pPr marL="0" indent="0">
               <a:buNone/>
             </a:pPr>
             <a:r>
@@ -5951,7 +5694,7 @@
           <a:bodyPr wrap="square" lIns="0" tIns="0" rIns="0" bIns="0" rtlCol="0" anchor="ctr"/>
           <a:lstStyle/>
           <a:p>
-            <a:pPr indent="0" marL="0">
+            <a:pPr marL="0" indent="0">
               <a:buNone/>
             </a:pPr>
             <a:r>
@@ -5990,7 +5733,7 @@
           <a:bodyPr wrap="square" lIns="0" tIns="0" rIns="0" bIns="0" rtlCol="0" anchor="ctr"/>
           <a:lstStyle/>
           <a:p>
-            <a:pPr indent="0" marL="0">
+            <a:pPr marL="0" indent="0">
               <a:buNone/>
             </a:pPr>
             <a:r>
@@ -6056,7 +5799,7 @@
           <a:bodyPr wrap="square" lIns="0" tIns="0" rIns="0" bIns="0" rtlCol="0" anchor="ctr"/>
           <a:lstStyle/>
           <a:p>
-            <a:pPr indent="0" marL="0">
+            <a:pPr marL="0" indent="0">
               <a:buNone/>
             </a:pPr>
             <a:r>
@@ -6095,7 +5838,7 @@
           <a:bodyPr wrap="square" lIns="0" tIns="0" rIns="0" bIns="0" rtlCol="0" anchor="ctr"/>
           <a:lstStyle/>
           <a:p>
-            <a:pPr indent="0" marL="0">
+            <a:pPr marL="0" indent="0">
               <a:buNone/>
             </a:pPr>
             <a:r>
@@ -6161,7 +5904,7 @@
           <a:bodyPr wrap="square" lIns="0" tIns="0" rIns="0" bIns="0" rtlCol="0" anchor="ctr"/>
           <a:lstStyle/>
           <a:p>
-            <a:pPr indent="0" marL="0">
+            <a:pPr marL="0" indent="0">
               <a:buNone/>
             </a:pPr>
             <a:r>
@@ -6200,7 +5943,7 @@
           <a:bodyPr wrap="square" lIns="0" tIns="0" rIns="0" bIns="0" rtlCol="0" anchor="ctr"/>
           <a:lstStyle/>
           <a:p>
-            <a:pPr indent="0" marL="0">
+            <a:pPr marL="0" indent="0">
               <a:buNone/>
             </a:pPr>
             <a:r>
@@ -6234,6 +5977,7 @@
         <a:solidFill>
           <a:srgbClr val="16100A"/>
         </a:solidFill>
+        <a:effectLst/>
       </p:bgPr>
     </p:bg>
     <p:spTree>
@@ -6271,7 +6015,7 @@
           <a:bodyPr wrap="square" lIns="0" tIns="0" rIns="0" bIns="0" rtlCol="0" anchor="ctr"/>
           <a:lstStyle/>
           <a:p>
-            <a:pPr indent="0" marL="0">
+            <a:pPr marL="0" indent="0">
               <a:buNone/>
             </a:pPr>
             <a:r>
@@ -6310,7 +6054,7 @@
           <a:bodyPr wrap="square" lIns="0" tIns="0" rIns="0" bIns="0" rtlCol="0" anchor="ctr"/>
           <a:lstStyle/>
           <a:p>
-            <a:pPr algn="r" indent="0" marL="0">
+            <a:pPr marL="0" indent="0" algn="r">
               <a:buNone/>
             </a:pPr>
             <a:r>
@@ -6349,11 +6093,11 @@
           <a:bodyPr wrap="square" lIns="0" tIns="0" rIns="0" bIns="0" rtlCol="0" anchor="ctr"/>
           <a:lstStyle/>
           <a:p>
-            <a:pPr indent="0" marL="0">
-              <a:buNone/>
-            </a:pPr>
-            <a:r>
-              <a:rPr lang="en-US" sz="1100" b="1" spc="300" kern="0" dirty="0">
+            <a:pPr marL="0" indent="0">
+              <a:buNone/>
+            </a:pPr>
+            <a:r>
+              <a:rPr lang="en-US" sz="1100" b="1" kern="0" spc="300" dirty="0">
                 <a:solidFill>
                   <a:srgbClr val="D08A57"/>
                 </a:solidFill>
@@ -6388,7 +6132,7 @@
           <a:bodyPr wrap="square" lIns="0" tIns="0" rIns="0" bIns="0" rtlCol="0" anchor="ctr"/>
           <a:lstStyle/>
           <a:p>
-            <a:pPr indent="0" marL="0">
+            <a:pPr marL="0" indent="0">
               <a:buNone/>
             </a:pPr>
             <a:r>
@@ -6427,7 +6171,7 @@
           <a:bodyPr wrap="square" lIns="0" tIns="0" rIns="0" bIns="0" rtlCol="0" anchor="ctr"/>
           <a:lstStyle/>
           <a:p>
-            <a:pPr indent="0" marL="0">
+            <a:pPr marL="0" indent="0">
               <a:buNone/>
             </a:pPr>
             <a:r>
@@ -6493,7 +6237,7 @@
           <a:bodyPr wrap="square" lIns="0" tIns="0" rIns="0" bIns="0" rtlCol="0" anchor="ctr"/>
           <a:lstStyle/>
           <a:p>
-            <a:pPr indent="0" marL="0">
+            <a:pPr marL="0" indent="0">
               <a:buNone/>
             </a:pPr>
             <a:r>
@@ -6532,7 +6276,7 @@
           <a:bodyPr wrap="square" lIns="0" tIns="0" rIns="0" bIns="0" rtlCol="0" anchor="ctr"/>
           <a:lstStyle/>
           <a:p>
-            <a:pPr indent="0" marL="0">
+            <a:pPr marL="0" indent="0">
               <a:buNone/>
             </a:pPr>
             <a:r>
@@ -6598,7 +6342,7 @@
           <a:bodyPr wrap="square" lIns="0" tIns="0" rIns="0" bIns="0" rtlCol="0" anchor="ctr"/>
           <a:lstStyle/>
           <a:p>
-            <a:pPr indent="0" marL="0">
+            <a:pPr marL="0" indent="0">
               <a:buNone/>
             </a:pPr>
             <a:r>
@@ -6637,7 +6381,7 @@
           <a:bodyPr wrap="square" lIns="0" tIns="0" rIns="0" bIns="0" rtlCol="0" anchor="ctr"/>
           <a:lstStyle/>
           <a:p>
-            <a:pPr indent="0" marL="0">
+            <a:pPr marL="0" indent="0">
               <a:buNone/>
             </a:pPr>
             <a:r>
@@ -6676,7 +6420,7 @@
           <a:bodyPr wrap="square" lIns="0" tIns="0" rIns="0" bIns="0" rtlCol="0" anchor="ctr"/>
           <a:lstStyle/>
           <a:p>
-            <a:pPr indent="0" marL="0">
+            <a:pPr marL="0" indent="0">
               <a:buNone/>
             </a:pPr>
             <a:r>
@@ -6742,7 +6486,7 @@
           <a:bodyPr wrap="square" lIns="0" tIns="0" rIns="0" bIns="0" rtlCol="0" anchor="ctr"/>
           <a:lstStyle/>
           <a:p>
-            <a:pPr algn="ctr" indent="0" marL="0">
+            <a:pPr marL="0" indent="0" algn="ctr">
               <a:buNone/>
             </a:pPr>
             <a:r>
@@ -6808,7 +6552,7 @@
           <a:bodyPr wrap="square" lIns="0" tIns="0" rIns="0" bIns="0" rtlCol="0" anchor="ctr"/>
           <a:lstStyle/>
           <a:p>
-            <a:pPr algn="ctr" indent="0" marL="0">
+            <a:pPr marL="0" indent="0" algn="ctr">
               <a:buNone/>
             </a:pPr>
             <a:r>
@@ -6874,7 +6618,7 @@
           <a:bodyPr wrap="square" lIns="0" tIns="0" rIns="0" bIns="0" rtlCol="0" anchor="ctr"/>
           <a:lstStyle/>
           <a:p>
-            <a:pPr algn="ctr" indent="0" marL="0">
+            <a:pPr marL="0" indent="0" algn="ctr">
               <a:buNone/>
             </a:pPr>
             <a:r>
@@ -6940,7 +6684,7 @@
           <a:bodyPr wrap="square" lIns="0" tIns="0" rIns="0" bIns="0" rtlCol="0" anchor="ctr"/>
           <a:lstStyle/>
           <a:p>
-            <a:pPr algn="ctr" indent="0" marL="0">
+            <a:pPr marL="0" indent="0" algn="ctr">
               <a:buNone/>
             </a:pPr>
             <a:r>
@@ -7006,7 +6750,7 @@
           <a:bodyPr wrap="square" lIns="0" tIns="0" rIns="0" bIns="0" rtlCol="0" anchor="ctr"/>
           <a:lstStyle/>
           <a:p>
-            <a:pPr algn="ctr" indent="0" marL="0">
+            <a:pPr marL="0" indent="0" algn="ctr">
               <a:buNone/>
             </a:pPr>
             <a:r>
@@ -7040,6 +6784,7 @@
         <a:solidFill>
           <a:srgbClr val="16100A"/>
         </a:solidFill>
+        <a:effectLst/>
       </p:bgPr>
     </p:bg>
     <p:spTree>
@@ -7077,7 +6822,7 @@
           <a:bodyPr wrap="square" lIns="0" tIns="0" rIns="0" bIns="0" rtlCol="0" anchor="ctr"/>
           <a:lstStyle/>
           <a:p>
-            <a:pPr indent="0" marL="0">
+            <a:pPr marL="0" indent="0">
               <a:buNone/>
             </a:pPr>
             <a:r>
@@ -7116,7 +6861,7 @@
           <a:bodyPr wrap="square" lIns="0" tIns="0" rIns="0" bIns="0" rtlCol="0" anchor="ctr"/>
           <a:lstStyle/>
           <a:p>
-            <a:pPr algn="r" indent="0" marL="0">
+            <a:pPr marL="0" indent="0" algn="r">
               <a:buNone/>
             </a:pPr>
             <a:r>
@@ -7155,11 +6900,11 @@
           <a:bodyPr wrap="square" lIns="0" tIns="0" rIns="0" bIns="0" rtlCol="0" anchor="ctr"/>
           <a:lstStyle/>
           <a:p>
-            <a:pPr indent="0" marL="0">
-              <a:buNone/>
-            </a:pPr>
-            <a:r>
-              <a:rPr lang="en-US" sz="1100" b="1" spc="300" kern="0" dirty="0">
+            <a:pPr marL="0" indent="0">
+              <a:buNone/>
+            </a:pPr>
+            <a:r>
+              <a:rPr lang="en-US" sz="1100" b="1" kern="0" spc="300" dirty="0">
                 <a:solidFill>
                   <a:srgbClr val="D08A57"/>
                 </a:solidFill>
@@ -7194,7 +6939,7 @@
           <a:bodyPr wrap="square" lIns="0" tIns="0" rIns="0" bIns="0" rtlCol="0" anchor="ctr"/>
           <a:lstStyle/>
           <a:p>
-            <a:pPr indent="0" marL="0">
+            <a:pPr marL="0" indent="0">
               <a:buNone/>
             </a:pPr>
             <a:r>
@@ -7260,7 +7005,7 @@
           <a:bodyPr wrap="square" lIns="0" tIns="0" rIns="0" bIns="0" rtlCol="0" anchor="ctr"/>
           <a:lstStyle/>
           <a:p>
-            <a:pPr indent="0" marL="0">
+            <a:pPr marL="0" indent="0">
               <a:buNone/>
             </a:pPr>
             <a:r>
@@ -7326,7 +7071,7 @@
           <a:bodyPr wrap="square" lIns="0" tIns="0" rIns="0" bIns="0" rtlCol="0" anchor="ctr"/>
           <a:lstStyle/>
           <a:p>
-            <a:pPr algn="ctr" indent="0" marL="0">
+            <a:pPr marL="0" indent="0" algn="ctr">
               <a:buNone/>
             </a:pPr>
             <a:r>
@@ -7365,7 +7110,7 @@
           <a:bodyPr wrap="square" lIns="0" tIns="0" rIns="0" bIns="0" rtlCol="0" anchor="ctr"/>
           <a:lstStyle/>
           <a:p>
-            <a:pPr indent="0" marL="0">
+            <a:pPr marL="0" indent="0">
               <a:buNone/>
             </a:pPr>
             <a:r>
@@ -7431,7 +7176,7 @@
           <a:bodyPr wrap="square" lIns="0" tIns="0" rIns="0" bIns="0" rtlCol="0" anchor="ctr"/>
           <a:lstStyle/>
           <a:p>
-            <a:pPr indent="0" marL="0">
+            <a:pPr marL="0" indent="0">
               <a:buNone/>
             </a:pPr>
             <a:r>
@@ -7497,7 +7242,7 @@
           <a:bodyPr wrap="square" lIns="0" tIns="0" rIns="0" bIns="0" rtlCol="0" anchor="ctr"/>
           <a:lstStyle/>
           <a:p>
-            <a:pPr algn="ctr" indent="0" marL="0">
+            <a:pPr marL="0" indent="0" algn="ctr">
               <a:buNone/>
             </a:pPr>
             <a:r>
@@ -7536,7 +7281,7 @@
           <a:bodyPr wrap="square" lIns="0" tIns="0" rIns="0" bIns="0" rtlCol="0" anchor="ctr"/>
           <a:lstStyle/>
           <a:p>
-            <a:pPr indent="0" marL="0">
+            <a:pPr marL="0" indent="0">
               <a:buNone/>
             </a:pPr>
             <a:r>
@@ -7602,7 +7347,7 @@
           <a:bodyPr wrap="square" lIns="0" tIns="0" rIns="0" bIns="0" rtlCol="0" anchor="ctr"/>
           <a:lstStyle/>
           <a:p>
-            <a:pPr indent="0" marL="0">
+            <a:pPr marL="0" indent="0">
               <a:buNone/>
             </a:pPr>
             <a:r>
@@ -7668,7 +7413,7 @@
           <a:bodyPr wrap="square" lIns="0" tIns="0" rIns="0" bIns="0" rtlCol="0" anchor="ctr"/>
           <a:lstStyle/>
           <a:p>
-            <a:pPr algn="ctr" indent="0" marL="0">
+            <a:pPr marL="0" indent="0" algn="ctr">
               <a:buNone/>
             </a:pPr>
             <a:r>
@@ -7707,7 +7452,7 @@
           <a:bodyPr wrap="square" lIns="0" tIns="0" rIns="0" bIns="0" rtlCol="0" anchor="ctr"/>
           <a:lstStyle/>
           <a:p>
-            <a:pPr indent="0" marL="0">
+            <a:pPr marL="0" indent="0">
               <a:buNone/>
             </a:pPr>
             <a:r>
@@ -7773,7 +7518,7 @@
           <a:bodyPr wrap="square" lIns="0" tIns="0" rIns="0" bIns="0" rtlCol="0" anchor="ctr"/>
           <a:lstStyle/>
           <a:p>
-            <a:pPr indent="0" marL="0">
+            <a:pPr marL="0" indent="0">
               <a:buNone/>
             </a:pPr>
             <a:r>
@@ -7839,7 +7584,7 @@
           <a:bodyPr wrap="square" lIns="0" tIns="0" rIns="0" bIns="0" rtlCol="0" anchor="ctr"/>
           <a:lstStyle/>
           <a:p>
-            <a:pPr algn="ctr" indent="0" marL="0">
+            <a:pPr marL="0" indent="0" algn="ctr">
               <a:buNone/>
             </a:pPr>
             <a:r>
@@ -7878,7 +7623,7 @@
           <a:bodyPr wrap="square" lIns="0" tIns="0" rIns="0" bIns="0" rtlCol="0" anchor="ctr"/>
           <a:lstStyle/>
           <a:p>
-            <a:pPr indent="0" marL="0">
+            <a:pPr marL="0" indent="0">
               <a:buNone/>
             </a:pPr>
             <a:r>
@@ -7944,7 +7689,7 @@
           <a:bodyPr wrap="square" lIns="0" tIns="0" rIns="0" bIns="0" rtlCol="0" anchor="ctr"/>
           <a:lstStyle/>
           <a:p>
-            <a:pPr indent="0" marL="0">
+            <a:pPr marL="0" indent="0">
               <a:buNone/>
             </a:pPr>
             <a:r>
@@ -8010,7 +7755,7 @@
           <a:bodyPr wrap="square" lIns="0" tIns="0" rIns="0" bIns="0" rtlCol="0" anchor="ctr"/>
           <a:lstStyle/>
           <a:p>
-            <a:pPr algn="ctr" indent="0" marL="0">
+            <a:pPr marL="0" indent="0" algn="ctr">
               <a:buNone/>
             </a:pPr>
             <a:r>
@@ -8049,7 +7794,7 @@
           <a:bodyPr wrap="square" lIns="0" tIns="0" rIns="0" bIns="0" rtlCol="0" anchor="ctr"/>
           <a:lstStyle/>
           <a:p>
-            <a:pPr indent="0" marL="0">
+            <a:pPr marL="0" indent="0">
               <a:buNone/>
             </a:pPr>
             <a:r>
@@ -8115,7 +7860,7 @@
           <a:bodyPr wrap="square" lIns="0" tIns="0" rIns="0" bIns="0" rtlCol="0" anchor="ctr"/>
           <a:lstStyle/>
           <a:p>
-            <a:pPr indent="0" marL="0">
+            <a:pPr marL="0" indent="0">
               <a:buNone/>
             </a:pPr>
             <a:r>
@@ -8181,7 +7926,7 @@
           <a:bodyPr wrap="square" lIns="0" tIns="0" rIns="0" bIns="0" rtlCol="0" anchor="ctr"/>
           <a:lstStyle/>
           <a:p>
-            <a:pPr algn="ctr" indent="0" marL="0">
+            <a:pPr marL="0" indent="0" algn="ctr">
               <a:buNone/>
             </a:pPr>
             <a:r>
@@ -8220,7 +7965,7 @@
           <a:bodyPr wrap="square" lIns="0" tIns="0" rIns="0" bIns="0" rtlCol="0" anchor="ctr"/>
           <a:lstStyle/>
           <a:p>
-            <a:pPr indent="0" marL="0">
+            <a:pPr marL="0" indent="0">
               <a:buNone/>
             </a:pPr>
             <a:r>
@@ -8259,7 +8004,7 @@
           <a:bodyPr wrap="square" lIns="0" tIns="0" rIns="0" bIns="0" rtlCol="0" anchor="ctr"/>
           <a:lstStyle/>
           <a:p>
-            <a:pPr algn="ctr" indent="0" marL="0">
+            <a:pPr marL="0" indent="0" algn="ctr">
               <a:buNone/>
             </a:pPr>
             <a:r>
@@ -8293,6 +8038,7 @@
         <a:solidFill>
           <a:srgbClr val="16100A"/>
         </a:solidFill>
+        <a:effectLst/>
       </p:bgPr>
     </p:bg>
     <p:spTree>
@@ -8330,7 +8076,7 @@
           <a:bodyPr wrap="square" lIns="0" tIns="0" rIns="0" bIns="0" rtlCol="0" anchor="ctr"/>
           <a:lstStyle/>
           <a:p>
-            <a:pPr indent="0" marL="0">
+            <a:pPr marL="0" indent="0">
               <a:buNone/>
             </a:pPr>
             <a:r>
@@ -8369,7 +8115,7 @@
           <a:bodyPr wrap="square" lIns="0" tIns="0" rIns="0" bIns="0" rtlCol="0" anchor="ctr"/>
           <a:lstStyle/>
           <a:p>
-            <a:pPr algn="r" indent="0" marL="0">
+            <a:pPr marL="0" indent="0" algn="r">
               <a:buNone/>
             </a:pPr>
             <a:r>
@@ -8408,11 +8154,11 @@
           <a:bodyPr wrap="square" lIns="0" tIns="0" rIns="0" bIns="0" rtlCol="0" anchor="ctr"/>
           <a:lstStyle/>
           <a:p>
-            <a:pPr indent="0" marL="0">
-              <a:buNone/>
-            </a:pPr>
-            <a:r>
-              <a:rPr lang="en-US" sz="1100" b="1" spc="300" kern="0" dirty="0">
+            <a:pPr marL="0" indent="0">
+              <a:buNone/>
+            </a:pPr>
+            <a:r>
+              <a:rPr lang="en-US" sz="1100" b="1" kern="0" spc="300" dirty="0">
                 <a:solidFill>
                   <a:srgbClr val="D08A57"/>
                 </a:solidFill>
@@ -8447,7 +8193,7 @@
           <a:bodyPr wrap="square" lIns="0" tIns="0" rIns="0" bIns="0" rtlCol="0" anchor="ctr"/>
           <a:lstStyle/>
           <a:p>
-            <a:pPr indent="0" marL="0">
+            <a:pPr marL="0" indent="0">
               <a:buNone/>
             </a:pPr>
             <a:r>
@@ -8513,7 +8259,7 @@
           <a:bodyPr wrap="square" lIns="0" tIns="0" rIns="0" bIns="0" rtlCol="0" anchor="ctr"/>
           <a:lstStyle/>
           <a:p>
-            <a:pPr indent="0" marL="0">
+            <a:pPr marL="0" indent="0">
               <a:buNone/>
             </a:pPr>
             <a:r>
@@ -8552,7 +8298,7 @@
           <a:bodyPr wrap="square" lIns="0" tIns="0" rIns="0" bIns="0" rtlCol="0" anchor="ctr"/>
           <a:lstStyle/>
           <a:p>
-            <a:pPr indent="0" marL="0">
+            <a:pPr marL="0" indent="0">
               <a:buNone/>
             </a:pPr>
             <a:r>
@@ -8618,7 +8364,7 @@
           <a:bodyPr wrap="square" lIns="0" tIns="0" rIns="0" bIns="0" rtlCol="0" anchor="ctr"/>
           <a:lstStyle/>
           <a:p>
-            <a:pPr algn="ctr" indent="0" marL="0">
+            <a:pPr marL="0" indent="0" algn="ctr">
               <a:buNone/>
             </a:pPr>
             <a:r>
@@ -8657,7 +8403,7 @@
           <a:bodyPr wrap="square" lIns="0" tIns="0" rIns="0" bIns="0" rtlCol="0" anchor="ctr"/>
           <a:lstStyle/>
           <a:p>
-            <a:pPr algn="ctr" indent="0" marL="0">
+            <a:pPr marL="0" indent="0" algn="ctr">
               <a:buNone/>
             </a:pPr>
             <a:r>
@@ -8723,7 +8469,7 @@
           <a:bodyPr wrap="square" lIns="0" tIns="0" rIns="0" bIns="0" rtlCol="0" anchor="ctr"/>
           <a:lstStyle/>
           <a:p>
-            <a:pPr indent="0" marL="0">
+            <a:pPr marL="0" indent="0">
               <a:buNone/>
             </a:pPr>
             <a:r>
@@ -8762,7 +8508,7 @@
           <a:bodyPr wrap="square" lIns="0" tIns="0" rIns="0" bIns="0" rtlCol="0" anchor="ctr"/>
           <a:lstStyle/>
           <a:p>
-            <a:pPr indent="0" marL="0">
+            <a:pPr marL="0" indent="0">
               <a:buNone/>
             </a:pPr>
             <a:r>
@@ -8828,7 +8574,7 @@
           <a:bodyPr wrap="square" lIns="0" tIns="0" rIns="0" bIns="0" rtlCol="0" anchor="ctr"/>
           <a:lstStyle/>
           <a:p>
-            <a:pPr algn="ctr" indent="0" marL="0">
+            <a:pPr marL="0" indent="0" algn="ctr">
               <a:buNone/>
             </a:pPr>
             <a:r>
@@ -8867,7 +8613,7 @@
           <a:bodyPr wrap="square" lIns="0" tIns="0" rIns="0" bIns="0" rtlCol="0" anchor="ctr"/>
           <a:lstStyle/>
           <a:p>
-            <a:pPr algn="ctr" indent="0" marL="0">
+            <a:pPr marL="0" indent="0" algn="ctr">
               <a:buNone/>
             </a:pPr>
             <a:r>
@@ -8933,7 +8679,7 @@
           <a:bodyPr wrap="square" lIns="0" tIns="0" rIns="0" bIns="0" rtlCol="0" anchor="ctr"/>
           <a:lstStyle/>
           <a:p>
-            <a:pPr indent="0" marL="0">
+            <a:pPr marL="0" indent="0">
               <a:buNone/>
             </a:pPr>
             <a:r>
@@ -8972,7 +8718,7 @@
           <a:bodyPr wrap="square" lIns="0" tIns="0" rIns="0" bIns="0" rtlCol="0" anchor="ctr"/>
           <a:lstStyle/>
           <a:p>
-            <a:pPr indent="0" marL="0">
+            <a:pPr marL="0" indent="0">
               <a:buNone/>
             </a:pPr>
             <a:r>
@@ -9038,7 +8784,7 @@
           <a:bodyPr wrap="square" lIns="0" tIns="0" rIns="0" bIns="0" rtlCol="0" anchor="ctr"/>
           <a:lstStyle/>
           <a:p>
-            <a:pPr algn="ctr" indent="0" marL="0">
+            <a:pPr marL="0" indent="0" algn="ctr">
               <a:buNone/>
             </a:pPr>
             <a:r>
@@ -9077,7 +8823,7 @@
           <a:bodyPr wrap="square" lIns="0" tIns="0" rIns="0" bIns="0" rtlCol="0" anchor="ctr"/>
           <a:lstStyle/>
           <a:p>
-            <a:pPr algn="ctr" indent="0" marL="0">
+            <a:pPr marL="0" indent="0" algn="ctr">
               <a:buNone/>
             </a:pPr>
             <a:r>
@@ -9143,7 +8889,7 @@
           <a:bodyPr wrap="square" lIns="0" tIns="0" rIns="0" bIns="0" rtlCol="0" anchor="ctr"/>
           <a:lstStyle/>
           <a:p>
-            <a:pPr indent="0" marL="0">
+            <a:pPr marL="0" indent="0">
               <a:buNone/>
             </a:pPr>
             <a:r>
@@ -9182,7 +8928,7 @@
           <a:bodyPr wrap="square" lIns="0" tIns="0" rIns="0" bIns="0" rtlCol="0" anchor="ctr"/>
           <a:lstStyle/>
           <a:p>
-            <a:pPr indent="0" marL="0">
+            <a:pPr marL="0" indent="0">
               <a:buNone/>
             </a:pPr>
             <a:r>
@@ -9248,7 +8994,7 @@
           <a:bodyPr wrap="square" lIns="0" tIns="0" rIns="0" bIns="0" rtlCol="0" anchor="ctr"/>
           <a:lstStyle/>
           <a:p>
-            <a:pPr algn="ctr" indent="0" marL="0">
+            <a:pPr marL="0" indent="0" algn="ctr">
               <a:buNone/>
             </a:pPr>
             <a:r>
@@ -9287,7 +9033,7 @@
           <a:bodyPr wrap="square" lIns="0" tIns="0" rIns="0" bIns="0" rtlCol="0" anchor="ctr"/>
           <a:lstStyle/>
           <a:p>
-            <a:pPr algn="ctr" indent="0" marL="0">
+            <a:pPr marL="0" indent="0" algn="ctr">
               <a:buNone/>
             </a:pPr>
             <a:r>
@@ -9353,7 +9099,7 @@
           <a:bodyPr wrap="square" lIns="0" tIns="0" rIns="0" bIns="0" rtlCol="0" anchor="ctr"/>
           <a:lstStyle/>
           <a:p>
-            <a:pPr indent="0" marL="0">
+            <a:pPr marL="0" indent="0">
               <a:buNone/>
             </a:pPr>
             <a:r>
@@ -9392,7 +9138,7 @@
           <a:bodyPr wrap="square" lIns="0" tIns="0" rIns="0" bIns="0" rtlCol="0" anchor="ctr"/>
           <a:lstStyle/>
           <a:p>
-            <a:pPr indent="0" marL="0">
+            <a:pPr marL="0" indent="0">
               <a:buNone/>
             </a:pPr>
             <a:r>
@@ -9458,7 +9204,7 @@
           <a:bodyPr wrap="square" lIns="0" tIns="0" rIns="0" bIns="0" rtlCol="0" anchor="ctr"/>
           <a:lstStyle/>
           <a:p>
-            <a:pPr algn="ctr" indent="0" marL="0">
+            <a:pPr marL="0" indent="0" algn="ctr">
               <a:buNone/>
             </a:pPr>
             <a:r>
@@ -9497,7 +9243,7 @@
           <a:bodyPr wrap="square" lIns="0" tIns="0" rIns="0" bIns="0" rtlCol="0" anchor="ctr"/>
           <a:lstStyle/>
           <a:p>
-            <a:pPr algn="ctr" indent="0" marL="0">
+            <a:pPr marL="0" indent="0" algn="ctr">
               <a:buNone/>
             </a:pPr>
             <a:r>
@@ -9563,7 +9309,7 @@
           <a:bodyPr wrap="square" lIns="0" tIns="0" rIns="0" bIns="0" rtlCol="0" anchor="ctr"/>
           <a:lstStyle/>
           <a:p>
-            <a:pPr indent="0" marL="0">
+            <a:pPr marL="0" indent="0">
               <a:buNone/>
             </a:pPr>
             <a:r>
@@ -9602,7 +9348,7 @@
           <a:bodyPr wrap="square" lIns="0" tIns="0" rIns="0" bIns="0" rtlCol="0" anchor="ctr"/>
           <a:lstStyle/>
           <a:p>
-            <a:pPr indent="0" marL="0">
+            <a:pPr marL="0" indent="0">
               <a:buNone/>
             </a:pPr>
             <a:r>
@@ -9668,7 +9414,7 @@
           <a:bodyPr wrap="square" lIns="0" tIns="0" rIns="0" bIns="0" rtlCol="0" anchor="ctr"/>
           <a:lstStyle/>
           <a:p>
-            <a:pPr algn="ctr" indent="0" marL="0">
+            <a:pPr marL="0" indent="0" algn="ctr">
               <a:buNone/>
             </a:pPr>
             <a:r>
@@ -9702,6 +9448,7 @@
         <a:solidFill>
           <a:srgbClr val="16100A"/>
         </a:solidFill>
+        <a:effectLst/>
       </p:bgPr>
     </p:bg>
     <p:spTree>
@@ -9739,7 +9486,7 @@
           <a:bodyPr wrap="square" lIns="0" tIns="0" rIns="0" bIns="0" rtlCol="0" anchor="ctr"/>
           <a:lstStyle/>
           <a:p>
-            <a:pPr indent="0" marL="0">
+            <a:pPr marL="0" indent="0">
               <a:buNone/>
             </a:pPr>
             <a:r>
@@ -9778,7 +9525,7 @@
           <a:bodyPr wrap="square" lIns="0" tIns="0" rIns="0" bIns="0" rtlCol="0" anchor="ctr"/>
           <a:lstStyle/>
           <a:p>
-            <a:pPr algn="r" indent="0" marL="0">
+            <a:pPr marL="0" indent="0" algn="r">
               <a:buNone/>
             </a:pPr>
             <a:r>
@@ -9817,11 +9564,11 @@
           <a:bodyPr wrap="square" lIns="0" tIns="0" rIns="0" bIns="0" rtlCol="0" anchor="ctr"/>
           <a:lstStyle/>
           <a:p>
-            <a:pPr indent="0" marL="0">
-              <a:buNone/>
-            </a:pPr>
-            <a:r>
-              <a:rPr lang="en-US" sz="1100" b="1" spc="300" kern="0" dirty="0">
+            <a:pPr marL="0" indent="0">
+              <a:buNone/>
+            </a:pPr>
+            <a:r>
+              <a:rPr lang="en-US" sz="1100" b="1" kern="0" spc="300" dirty="0">
                 <a:solidFill>
                   <a:srgbClr val="D08A57"/>
                 </a:solidFill>
@@ -9856,7 +9603,7 @@
           <a:bodyPr wrap="square" lIns="0" tIns="0" rIns="0" bIns="0" rtlCol="0" anchor="ctr"/>
           <a:lstStyle/>
           <a:p>
-            <a:pPr indent="0" marL="0">
+            <a:pPr marL="0" indent="0">
               <a:buNone/>
             </a:pPr>
             <a:r>
@@ -9922,7 +9669,7 @@
           <a:bodyPr wrap="square" lIns="0" tIns="0" rIns="0" bIns="0" rtlCol="0" anchor="ctr"/>
           <a:lstStyle/>
           <a:p>
-            <a:pPr indent="0" marL="0">
+            <a:pPr marL="0" indent="0">
               <a:buNone/>
             </a:pPr>
             <a:r>
@@ -9961,7 +9708,7 @@
           <a:bodyPr wrap="square" lIns="0" tIns="0" rIns="0" bIns="0" rtlCol="0" anchor="ctr"/>
           <a:lstStyle/>
           <a:p>
-            <a:pPr indent="0" marL="0">
+            <a:pPr marL="0" indent="0">
               <a:buNone/>
             </a:pPr>
             <a:r>
@@ -10000,7 +9747,7 @@
           <a:bodyPr wrap="square" lIns="0" tIns="0" rIns="0" bIns="0" rtlCol="0" anchor="ctr"/>
           <a:lstStyle/>
           <a:p>
-            <a:pPr indent="0" marL="0">
+            <a:pPr marL="0" indent="0">
               <a:buNone/>
             </a:pPr>
             <a:r>
@@ -10039,7 +9786,7 @@
           <a:bodyPr wrap="square" lIns="0" tIns="0" rIns="0" bIns="0" rtlCol="0" anchor="ctr"/>
           <a:lstStyle/>
           <a:p>
-            <a:pPr indent="0" marL="0">
+            <a:pPr marL="0" indent="0">
               <a:buNone/>
             </a:pPr>
             <a:r>
@@ -10078,7 +9825,7 @@
           <a:bodyPr wrap="square" lIns="0" tIns="0" rIns="0" bIns="0" rtlCol="0" anchor="ctr"/>
           <a:lstStyle/>
           <a:p>
-            <a:pPr indent="0" marL="0">
+            <a:pPr marL="0" indent="0">
               <a:buNone/>
             </a:pPr>
             <a:r>
@@ -10117,7 +9864,7 @@
           <a:bodyPr wrap="square" lIns="0" tIns="0" rIns="0" bIns="0" rtlCol="0" anchor="ctr"/>
           <a:lstStyle/>
           <a:p>
-            <a:pPr indent="0" marL="0">
+            <a:pPr marL="0" indent="0">
               <a:buNone/>
             </a:pPr>
             <a:r>
@@ -10156,7 +9903,7 @@
           <a:bodyPr wrap="square" lIns="0" tIns="0" rIns="0" bIns="0" rtlCol="0" anchor="ctr"/>
           <a:lstStyle/>
           <a:p>
-            <a:pPr indent="0" marL="0">
+            <a:pPr marL="0" indent="0">
               <a:buNone/>
             </a:pPr>
             <a:r>
@@ -10195,7 +9942,7 @@
           <a:bodyPr wrap="square" lIns="0" tIns="0" rIns="0" bIns="0" rtlCol="0" anchor="ctr"/>
           <a:lstStyle/>
           <a:p>
-            <a:pPr indent="0" marL="0">
+            <a:pPr marL="0" indent="0">
               <a:buNone/>
             </a:pPr>
             <a:r>
@@ -10234,7 +9981,7 @@
           <a:bodyPr wrap="square" lIns="0" tIns="0" rIns="0" bIns="0" rtlCol="0" anchor="ctr"/>
           <a:lstStyle/>
           <a:p>
-            <a:pPr indent="0" marL="0">
+            <a:pPr marL="0" indent="0">
               <a:buNone/>
             </a:pPr>
             <a:r>
@@ -10273,7 +10020,7 @@
           <a:bodyPr wrap="square" lIns="0" tIns="0" rIns="0" bIns="0" rtlCol="0" anchor="ctr"/>
           <a:lstStyle/>
           <a:p>
-            <a:pPr indent="0" marL="0">
+            <a:pPr marL="0" indent="0">
               <a:buNone/>
             </a:pPr>
             <a:r>
@@ -10339,7 +10086,7 @@
           <a:bodyPr wrap="square" lIns="0" tIns="0" rIns="0" bIns="0" rtlCol="0" anchor="ctr"/>
           <a:lstStyle/>
           <a:p>
-            <a:pPr indent="0" marL="0">
+            <a:pPr marL="0" indent="0">
               <a:buNone/>
             </a:pPr>
             <a:r>
@@ -10460,7 +10207,7 @@
           <a:bodyPr wrap="square" lIns="0" tIns="0" rIns="0" bIns="0" rtlCol="0" anchor="ctr"/>
           <a:lstStyle/>
           <a:p>
-            <a:pPr indent="0" marL="0">
+            <a:pPr marL="0" indent="0">
               <a:buNone/>
             </a:pPr>
             <a:r>
@@ -10494,6 +10241,7 @@
         <a:solidFill>
           <a:srgbClr val="16100A"/>
         </a:solidFill>
+        <a:effectLst/>
       </p:bgPr>
     </p:bg>
     <p:spTree>
@@ -10531,7 +10279,7 @@
           <a:bodyPr wrap="square" lIns="0" tIns="0" rIns="0" bIns="0" rtlCol="0" anchor="ctr"/>
           <a:lstStyle/>
           <a:p>
-            <a:pPr indent="0" marL="0">
+            <a:pPr marL="0" indent="0">
               <a:buNone/>
             </a:pPr>
             <a:r>
@@ -10570,7 +10318,7 @@
           <a:bodyPr wrap="square" lIns="0" tIns="0" rIns="0" bIns="0" rtlCol="0" anchor="ctr"/>
           <a:lstStyle/>
           <a:p>
-            <a:pPr algn="r" indent="0" marL="0">
+            <a:pPr marL="0" indent="0" algn="r">
               <a:buNone/>
             </a:pPr>
             <a:r>
@@ -10609,11 +10357,11 @@
           <a:bodyPr wrap="square" lIns="0" tIns="0" rIns="0" bIns="0" rtlCol="0" anchor="ctr"/>
           <a:lstStyle/>
           <a:p>
-            <a:pPr indent="0" marL="0">
-              <a:buNone/>
-            </a:pPr>
-            <a:r>
-              <a:rPr lang="en-US" sz="1100" b="1" spc="300" kern="0" dirty="0">
+            <a:pPr marL="0" indent="0">
+              <a:buNone/>
+            </a:pPr>
+            <a:r>
+              <a:rPr lang="en-US" sz="1100" b="1" kern="0" spc="300" dirty="0">
                 <a:solidFill>
                   <a:srgbClr val="D08A57"/>
                 </a:solidFill>
@@ -10648,7 +10396,7 @@
           <a:bodyPr wrap="square" lIns="0" tIns="0" rIns="0" bIns="0" rtlCol="0" anchor="ctr"/>
           <a:lstStyle/>
           <a:p>
-            <a:pPr indent="0" marL="0">
+            <a:pPr marL="0" indent="0">
               <a:buNone/>
             </a:pPr>
             <a:r>
@@ -10714,7 +10462,7 @@
           <a:bodyPr wrap="square" lIns="0" tIns="0" rIns="0" bIns="0" rtlCol="0" anchor="ctr"/>
           <a:lstStyle/>
           <a:p>
-            <a:pPr indent="0" marL="0">
+            <a:pPr marL="0" indent="0">
               <a:buNone/>
             </a:pPr>
             <a:r>
@@ -10780,7 +10528,7 @@
           <a:bodyPr wrap="square" lIns="0" tIns="0" rIns="0" bIns="0" rtlCol="0" anchor="ctr"/>
           <a:lstStyle/>
           <a:p>
-            <a:pPr algn="ctr" indent="0" marL="0">
+            <a:pPr marL="0" indent="0" algn="ctr">
               <a:buNone/>
             </a:pPr>
             <a:r>
@@ -10819,7 +10567,7 @@
           <a:bodyPr wrap="square" lIns="0" tIns="0" rIns="0" bIns="0" rtlCol="0" anchor="ctr"/>
           <a:lstStyle/>
           <a:p>
-            <a:pPr indent="0" marL="0">
+            <a:pPr marL="0" indent="0">
               <a:buNone/>
             </a:pPr>
             <a:r>
@@ -10885,7 +10633,7 @@
           <a:bodyPr wrap="square" lIns="0" tIns="0" rIns="0" bIns="0" rtlCol="0" anchor="ctr"/>
           <a:lstStyle/>
           <a:p>
-            <a:pPr indent="0" marL="0">
+            <a:pPr marL="0" indent="0">
               <a:buNone/>
             </a:pPr>
             <a:r>
@@ -10951,7 +10699,7 @@
           <a:bodyPr wrap="square" lIns="0" tIns="0" rIns="0" bIns="0" rtlCol="0" anchor="ctr"/>
           <a:lstStyle/>
           <a:p>
-            <a:pPr algn="ctr" indent="0" marL="0">
+            <a:pPr marL="0" indent="0" algn="ctr">
               <a:buNone/>
             </a:pPr>
             <a:r>
@@ -10990,7 +10738,7 @@
           <a:bodyPr wrap="square" lIns="0" tIns="0" rIns="0" bIns="0" rtlCol="0" anchor="ctr"/>
           <a:lstStyle/>
           <a:p>
-            <a:pPr indent="0" marL="0">
+            <a:pPr marL="0" indent="0">
               <a:buNone/>
             </a:pPr>
             <a:r>
@@ -11056,7 +10804,7 @@
           <a:bodyPr wrap="square" lIns="0" tIns="0" rIns="0" bIns="0" rtlCol="0" anchor="ctr"/>
           <a:lstStyle/>
           <a:p>
-            <a:pPr indent="0" marL="0">
+            <a:pPr marL="0" indent="0">
               <a:buNone/>
             </a:pPr>
             <a:r>
@@ -11122,7 +10870,7 @@
           <a:bodyPr wrap="square" lIns="0" tIns="0" rIns="0" bIns="0" rtlCol="0" anchor="ctr"/>
           <a:lstStyle/>
           <a:p>
-            <a:pPr algn="ctr" indent="0" marL="0">
+            <a:pPr marL="0" indent="0" algn="ctr">
               <a:buNone/>
             </a:pPr>
             <a:r>
@@ -11161,7 +10909,7 @@
           <a:bodyPr wrap="square" lIns="0" tIns="0" rIns="0" bIns="0" rtlCol="0" anchor="ctr"/>
           <a:lstStyle/>
           <a:p>
-            <a:pPr indent="0" marL="0">
+            <a:pPr marL="0" indent="0">
               <a:buNone/>
             </a:pPr>
             <a:r>
@@ -11227,7 +10975,7 @@
           <a:bodyPr wrap="square" lIns="0" tIns="0" rIns="0" bIns="0" rtlCol="0" anchor="ctr"/>
           <a:lstStyle/>
           <a:p>
-            <a:pPr indent="0" marL="0">
+            <a:pPr marL="0" indent="0">
               <a:buNone/>
             </a:pPr>
             <a:r>
@@ -11293,7 +11041,7 @@
           <a:bodyPr wrap="square" lIns="0" tIns="0" rIns="0" bIns="0" rtlCol="0" anchor="ctr"/>
           <a:lstStyle/>
           <a:p>
-            <a:pPr algn="ctr" indent="0" marL="0">
+            <a:pPr marL="0" indent="0" algn="ctr">
               <a:buNone/>
             </a:pPr>
             <a:r>
@@ -11332,7 +11080,7 @@
           <a:bodyPr wrap="square" lIns="0" tIns="0" rIns="0" bIns="0" rtlCol="0" anchor="ctr"/>
           <a:lstStyle/>
           <a:p>
-            <a:pPr indent="0" marL="0">
+            <a:pPr marL="0" indent="0">
               <a:buNone/>
             </a:pPr>
             <a:r>
@@ -11371,7 +11119,7 @@
           <a:bodyPr wrap="square" lIns="0" tIns="0" rIns="0" bIns="0" rtlCol="0" anchor="ctr"/>
           <a:lstStyle/>
           <a:p>
-            <a:pPr algn="ctr" indent="0" marL="0">
+            <a:pPr marL="0" indent="0" algn="ctr">
               <a:buNone/>
             </a:pPr>
             <a:r>
@@ -11405,6 +11153,7 @@
         <a:solidFill>
           <a:srgbClr val="16100A"/>
         </a:solidFill>
+        <a:effectLst/>
       </p:bgPr>
     </p:bg>
     <p:spTree>
@@ -11442,7 +11191,7 @@
           <a:bodyPr wrap="square" lIns="0" tIns="0" rIns="0" bIns="0" rtlCol="0" anchor="ctr"/>
           <a:lstStyle/>
           <a:p>
-            <a:pPr indent="0" marL="0">
+            <a:pPr marL="0" indent="0">
               <a:buNone/>
             </a:pPr>
             <a:r>
@@ -11481,7 +11230,7 @@
           <a:bodyPr wrap="square" lIns="0" tIns="0" rIns="0" bIns="0" rtlCol="0" anchor="ctr"/>
           <a:lstStyle/>
           <a:p>
-            <a:pPr algn="r" indent="0" marL="0">
+            <a:pPr marL="0" indent="0" algn="r">
               <a:buNone/>
             </a:pPr>
             <a:r>
@@ -11520,11 +11269,11 @@
           <a:bodyPr wrap="square" lIns="0" tIns="0" rIns="0" bIns="0" rtlCol="0" anchor="ctr"/>
           <a:lstStyle/>
           <a:p>
-            <a:pPr indent="0" marL="0">
-              <a:buNone/>
-            </a:pPr>
-            <a:r>
-              <a:rPr lang="en-US" sz="1100" b="1" spc="300" kern="0" dirty="0">
+            <a:pPr marL="0" indent="0">
+              <a:buNone/>
+            </a:pPr>
+            <a:r>
+              <a:rPr lang="en-US" sz="1100" b="1" kern="0" spc="300" dirty="0">
                 <a:solidFill>
                   <a:srgbClr val="D08A57"/>
                 </a:solidFill>
@@ -11559,7 +11308,7 @@
           <a:bodyPr wrap="square" lIns="0" tIns="0" rIns="0" bIns="0" rtlCol="0" anchor="ctr"/>
           <a:lstStyle/>
           <a:p>
-            <a:pPr indent="0" marL="0">
+            <a:pPr marL="0" indent="0">
               <a:buNone/>
             </a:pPr>
             <a:r>
@@ -11598,7 +11347,7 @@
           <a:bodyPr wrap="square" lIns="0" tIns="0" rIns="0" bIns="0" rtlCol="0" anchor="ctr"/>
           <a:lstStyle/>
           <a:p>
-            <a:pPr indent="0" marL="0">
+            <a:pPr marL="0" indent="0">
               <a:buNone/>
             </a:pPr>
             <a:r>
@@ -11664,7 +11413,7 @@
           <a:bodyPr wrap="square" lIns="0" tIns="0" rIns="0" bIns="0" rtlCol="0" anchor="ctr"/>
           <a:lstStyle/>
           <a:p>
-            <a:pPr indent="0" marL="0">
+            <a:pPr marL="0" indent="0">
               <a:buNone/>
             </a:pPr>
             <a:r>
@@ -11703,7 +11452,7 @@
           <a:bodyPr wrap="square" lIns="0" tIns="0" rIns="0" bIns="0" rtlCol="0" anchor="ctr"/>
           <a:lstStyle/>
           <a:p>
-            <a:pPr indent="0" marL="0">
+            <a:pPr marL="0" indent="0">
               <a:buNone/>
             </a:pPr>
             <a:r>
@@ -11769,7 +11518,7 @@
           <a:bodyPr wrap="square" lIns="0" tIns="0" rIns="0" bIns="0" rtlCol="0" anchor="ctr"/>
           <a:lstStyle/>
           <a:p>
-            <a:pPr indent="0" marL="0">
+            <a:pPr marL="0" indent="0">
               <a:buNone/>
             </a:pPr>
             <a:r>
@@ -11808,7 +11557,7 @@
           <a:bodyPr wrap="square" lIns="0" tIns="0" rIns="0" bIns="0" rtlCol="0" anchor="ctr"/>
           <a:lstStyle/>
           <a:p>
-            <a:pPr indent="0" marL="0">
+            <a:pPr marL="0" indent="0">
               <a:buNone/>
             </a:pPr>
             <a:r>
@@ -11847,7 +11596,7 @@
           <a:bodyPr wrap="square" lIns="0" tIns="0" rIns="0" bIns="0" rtlCol="0" anchor="ctr"/>
           <a:lstStyle/>
           <a:p>
-            <a:pPr indent="0" marL="0">
+            <a:pPr marL="0" indent="0">
               <a:buNone/>
             </a:pPr>
             <a:r>
@@ -11881,6 +11630,7 @@
         <a:solidFill>
           <a:srgbClr val="16100A"/>
         </a:solidFill>
+        <a:effectLst/>
       </p:bgPr>
     </p:bg>
     <p:spTree>
@@ -11918,7 +11668,7 @@
           <a:bodyPr wrap="square" lIns="0" tIns="0" rIns="0" bIns="0" rtlCol="0" anchor="ctr"/>
           <a:lstStyle/>
           <a:p>
-            <a:pPr indent="0" marL="0">
+            <a:pPr marL="0" indent="0">
               <a:buNone/>
             </a:pPr>
             <a:r>
@@ -11957,7 +11707,7 @@
           <a:bodyPr wrap="square" lIns="0" tIns="0" rIns="0" bIns="0" rtlCol="0" anchor="ctr"/>
           <a:lstStyle/>
           <a:p>
-            <a:pPr algn="r" indent="0" marL="0">
+            <a:pPr marL="0" indent="0" algn="r">
               <a:buNone/>
             </a:pPr>
             <a:r>
@@ -11996,11 +11746,11 @@
           <a:bodyPr wrap="square" lIns="0" tIns="0" rIns="0" bIns="0" rtlCol="0" anchor="ctr"/>
           <a:lstStyle/>
           <a:p>
-            <a:pPr indent="0" marL="0">
-              <a:buNone/>
-            </a:pPr>
-            <a:r>
-              <a:rPr lang="en-US" sz="1100" b="1" spc="300" kern="0" dirty="0">
+            <a:pPr marL="0" indent="0">
+              <a:buNone/>
+            </a:pPr>
+            <a:r>
+              <a:rPr lang="en-US" sz="1100" b="1" kern="0" spc="300" dirty="0">
                 <a:solidFill>
                   <a:srgbClr val="D08A57"/>
                 </a:solidFill>
@@ -12035,7 +11785,7 @@
           <a:bodyPr wrap="square" lIns="0" tIns="0" rIns="0" bIns="0" rtlCol="0" anchor="ctr"/>
           <a:lstStyle/>
           <a:p>
-            <a:pPr indent="0" marL="0">
+            <a:pPr marL="0" indent="0">
               <a:buNone/>
             </a:pPr>
             <a:r>
@@ -12101,7 +11851,7 @@
           <a:bodyPr wrap="square" lIns="0" tIns="0" rIns="0" bIns="0" rtlCol="0" anchor="ctr"/>
           <a:lstStyle/>
           <a:p>
-            <a:pPr algn="ctr" indent="0" marL="0">
+            <a:pPr marL="0" indent="0" algn="ctr">
               <a:buNone/>
             </a:pPr>
             <a:r>
@@ -12140,7 +11890,7 @@
           <a:bodyPr wrap="square" lIns="0" tIns="0" rIns="0" bIns="0" rtlCol="0" anchor="ctr"/>
           <a:lstStyle/>
           <a:p>
-            <a:pPr algn="ctr" indent="0" marL="0">
+            <a:pPr marL="0" indent="0" algn="ctr">
               <a:buNone/>
             </a:pPr>
             <a:r>
@@ -12206,7 +11956,7 @@
           <a:bodyPr wrap="square" lIns="0" tIns="0" rIns="0" bIns="0" rtlCol="0" anchor="ctr"/>
           <a:lstStyle/>
           <a:p>
-            <a:pPr algn="ctr" indent="0" marL="0">
+            <a:pPr marL="0" indent="0" algn="ctr">
               <a:buNone/>
             </a:pPr>
             <a:r>
@@ -12245,7 +11995,7 @@
           <a:bodyPr wrap="square" lIns="0" tIns="0" rIns="0" bIns="0" rtlCol="0" anchor="ctr"/>
           <a:lstStyle/>
           <a:p>
-            <a:pPr algn="ctr" indent="0" marL="0">
+            <a:pPr marL="0" indent="0" algn="ctr">
               <a:buNone/>
             </a:pPr>
             <a:r>
@@ -12311,7 +12061,7 @@
           <a:bodyPr wrap="square" lIns="0" tIns="0" rIns="0" bIns="0" rtlCol="0" anchor="ctr"/>
           <a:lstStyle/>
           <a:p>
-            <a:pPr algn="ctr" indent="0" marL="0">
+            <a:pPr marL="0" indent="0" algn="ctr">
               <a:buNone/>
             </a:pPr>
             <a:r>
@@ -12350,7 +12100,7 @@
           <a:bodyPr wrap="square" lIns="0" tIns="0" rIns="0" bIns="0" rtlCol="0" anchor="ctr"/>
           <a:lstStyle/>
           <a:p>
-            <a:pPr algn="ctr" indent="0" marL="0">
+            <a:pPr marL="0" indent="0" algn="ctr">
               <a:buNone/>
             </a:pPr>
             <a:r>
@@ -12416,7 +12166,7 @@
           <a:bodyPr wrap="square" lIns="0" tIns="0" rIns="0" bIns="0" rtlCol="0" anchor="ctr"/>
           <a:lstStyle/>
           <a:p>
-            <a:pPr algn="ctr" indent="0" marL="0">
+            <a:pPr marL="0" indent="0" algn="ctr">
               <a:buNone/>
             </a:pPr>
             <a:r>
@@ -12455,7 +12205,7 @@
           <a:bodyPr wrap="square" lIns="0" tIns="0" rIns="0" bIns="0" rtlCol="0" anchor="ctr"/>
           <a:lstStyle/>
           <a:p>
-            <a:pPr algn="ctr" indent="0" marL="0">
+            <a:pPr marL="0" indent="0" algn="ctr">
               <a:buNone/>
             </a:pPr>
             <a:r>
@@ -12521,7 +12271,7 @@
           <a:bodyPr wrap="square" lIns="0" tIns="0" rIns="0" bIns="0" rtlCol="0" anchor="ctr"/>
           <a:lstStyle/>
           <a:p>
-            <a:pPr algn="ctr" indent="0" marL="0">
+            <a:pPr marL="0" indent="0" algn="ctr">
               <a:buNone/>
             </a:pPr>
             <a:r>
@@ -12669,7 +12419,7 @@
           <a:bodyPr wrap="square" lIns="0" tIns="0" rIns="0" bIns="0" rtlCol="0" anchor="ctr"/>
           <a:lstStyle/>
           <a:p>
-            <a:pPr indent="0" marL="0">
+            <a:pPr marL="0" indent="0">
               <a:buNone/>
             </a:pPr>
             <a:r>
@@ -12988,4 +12738,299 @@
     </a:ext>
   </a:extLst>
 </a:theme>
+</file>
+
+<file path=ppt/theme/theme2.xml><?xml version="1.0" encoding="utf-8"?>
+<a:theme xmlns:a="http://schemas.openxmlformats.org/drawingml/2006/main" name="Office Theme">
+  <a:themeElements>
+    <a:clrScheme name="Office">
+      <a:dk1>
+        <a:sysClr val="windowText" lastClr="000000"/>
+      </a:dk1>
+      <a:lt1>
+        <a:sysClr val="window" lastClr="FFFFFF"/>
+      </a:lt1>
+      <a:dk2>
+        <a:srgbClr val="44546A"/>
+      </a:dk2>
+      <a:lt2>
+        <a:srgbClr val="E7E6E6"/>
+      </a:lt2>
+      <a:accent1>
+        <a:srgbClr val="4472C4"/>
+      </a:accent1>
+      <a:accent2>
+        <a:srgbClr val="ED7D31"/>
+      </a:accent2>
+      <a:accent3>
+        <a:srgbClr val="A5A5A5"/>
+      </a:accent3>
+      <a:accent4>
+        <a:srgbClr val="FFC000"/>
+      </a:accent4>
+      <a:accent5>
+        <a:srgbClr val="5B9BD5"/>
+      </a:accent5>
+      <a:accent6>
+        <a:srgbClr val="70AD47"/>
+      </a:accent6>
+      <a:hlink>
+        <a:srgbClr val="0563C1"/>
+      </a:hlink>
+      <a:folHlink>
+        <a:srgbClr val="954F72"/>
+      </a:folHlink>
+    </a:clrScheme>
+    <a:fontScheme name="Office">
+      <a:majorFont>
+        <a:latin typeface="Calibri Light" panose="020F0302020204030204"/>
+        <a:ea typeface=""/>
+        <a:cs typeface=""/>
+        <a:font script="Jpan" typeface="游ゴシック Light"/>
+        <a:font script="Hang" typeface="맑은 고딕"/>
+        <a:font script="Hans" typeface="等线 Light"/>
+        <a:font script="Hant" typeface="新細明體"/>
+        <a:font script="Arab" typeface="Times New Roman"/>
+        <a:font script="Hebr" typeface="Times New Roman"/>
+        <a:font script="Thai" typeface="Angsana New"/>
+        <a:font script="Ethi" typeface="Nyala"/>
+        <a:font script="Beng" typeface="Vrinda"/>
+        <a:font script="Gujr" typeface="Shruti"/>
+        <a:font script="Khmr" typeface="MoolBoran"/>
+        <a:font script="Knda" typeface="Tunga"/>
+        <a:font script="Guru" typeface="Raavi"/>
+        <a:font script="Cans" typeface="Euphemia"/>
+        <a:font script="Cher" typeface="Plantagenet Cherokee"/>
+        <a:font script="Yiii" typeface="Microsoft Yi Baiti"/>
+        <a:font script="Tibt" typeface="Microsoft Himalaya"/>
+        <a:font script="Thaa" typeface="MV Boli"/>
+        <a:font script="Deva" typeface="Mangal"/>
+        <a:font script="Telu" typeface="Gautami"/>
+        <a:font script="Taml" typeface="Latha"/>
+        <a:font script="Syrc" typeface="Estrangelo Edessa"/>
+        <a:font script="Orya" typeface="Kalinga"/>
+        <a:font script="Mlym" typeface="Kartika"/>
+        <a:font script="Laoo" typeface="DokChampa"/>
+        <a:font script="Sinh" typeface="Iskoola Pota"/>
+        <a:font script="Mong" typeface="Mongolian Baiti"/>
+        <a:font script="Viet" typeface="Times New Roman"/>
+        <a:font script="Uigh" typeface="Microsoft Uighur"/>
+        <a:font script="Geor" typeface="Sylfaen"/>
+        <a:font script="Armn" typeface="Arial"/>
+        <a:font script="Bugi" typeface="Leelawadee UI"/>
+        <a:font script="Bopo" typeface="Microsoft JhengHei"/>
+        <a:font script="Java" typeface="Javanese Text"/>
+        <a:font script="Lisu" typeface="Segoe UI"/>
+        <a:font script="Mymr" typeface="Myanmar Text"/>
+        <a:font script="Nkoo" typeface="Ebrima"/>
+        <a:font script="Olck" typeface="Nirmala UI"/>
+        <a:font script="Osma" typeface="Ebrima"/>
+        <a:font script="Phag" typeface="Phagspa"/>
+        <a:font script="Syrn" typeface="Estrangelo Edessa"/>
+        <a:font script="Syrj" typeface="Estrangelo Edessa"/>
+        <a:font script="Syre" typeface="Estrangelo Edessa"/>
+        <a:font script="Sora" typeface="Nirmala UI"/>
+        <a:font script="Tale" typeface="Microsoft Tai Le"/>
+        <a:font script="Talu" typeface="Microsoft New Tai Lue"/>
+        <a:font script="Tfng" typeface="Ebrima"/>
+      </a:majorFont>
+      <a:minorFont>
+        <a:latin typeface="Calibri" panose="020F0502020204030204"/>
+        <a:ea typeface=""/>
+        <a:cs typeface=""/>
+        <a:font script="Jpan" typeface="游ゴシック"/>
+        <a:font script="Hang" typeface="맑은 고딕"/>
+        <a:font script="Hans" typeface="等线"/>
+        <a:font script="Hant" typeface="新細明體"/>
+        <a:font script="Arab" typeface="Arial"/>
+        <a:font script="Hebr" typeface="Arial"/>
+        <a:font script="Thai" typeface="Cordia New"/>
+        <a:font script="Ethi" typeface="Nyala"/>
+        <a:font script="Beng" typeface="Vrinda"/>
+        <a:font script="Gujr" typeface="Shruti"/>
+        <a:font script="Khmr" typeface="DaunPenh"/>
+        <a:font script="Knda" typeface="Tunga"/>
+        <a:font script="Guru" typeface="Raavi"/>
+        <a:font script="Cans" typeface="Euphemia"/>
+        <a:font script="Cher" typeface="Plantagenet Cherokee"/>
+        <a:font script="Yiii" typeface="Microsoft Yi Baiti"/>
+        <a:font script="Tibt" typeface="Microsoft Himalaya"/>
+        <a:font script="Thaa" typeface="MV Boli"/>
+        <a:font script="Deva" typeface="Mangal"/>
+        <a:font script="Telu" typeface="Gautami"/>
+        <a:font script="Taml" typeface="Latha"/>
+        <a:font script="Syrc" typeface="Estrangelo Edessa"/>
+        <a:font script="Orya" typeface="Kalinga"/>
+        <a:font script="Mlym" typeface="Kartika"/>
+        <a:font script="Laoo" typeface="DokChampa"/>
+        <a:font script="Sinh" typeface="Iskoola Pota"/>
+        <a:font script="Mong" typeface="Mongolian Baiti"/>
+        <a:font script="Viet" typeface="Arial"/>
+        <a:font script="Uigh" typeface="Microsoft Uighur"/>
+        <a:font script="Geor" typeface="Sylfaen"/>
+        <a:font script="Armn" typeface="Arial"/>
+        <a:font script="Bugi" typeface="Leelawadee UI"/>
+        <a:font script="Bopo" typeface="Microsoft JhengHei"/>
+        <a:font script="Java" typeface="Javanese Text"/>
+        <a:font script="Lisu" typeface="Segoe UI"/>
+        <a:font script="Mymr" typeface="Myanmar Text"/>
+        <a:font script="Nkoo" typeface="Ebrima"/>
+        <a:font script="Olck" typeface="Nirmala UI"/>
+        <a:font script="Osma" typeface="Ebrima"/>
+        <a:font script="Phag" typeface="Phagspa"/>
+        <a:font script="Syrn" typeface="Estrangelo Edessa"/>
+        <a:font script="Syrj" typeface="Estrangelo Edessa"/>
+        <a:font script="Syre" typeface="Estrangelo Edessa"/>
+        <a:font script="Sora" typeface="Nirmala UI"/>
+        <a:font script="Tale" typeface="Microsoft Tai Le"/>
+        <a:font script="Talu" typeface="Microsoft New Tai Lue"/>
+        <a:font script="Tfng" typeface="Ebrima"/>
+      </a:minorFont>
+    </a:fontScheme>
+    <a:fmtScheme name="Office">
+      <a:fillStyleLst>
+        <a:solidFill>
+          <a:schemeClr val="phClr"/>
+        </a:solidFill>
+        <a:gradFill rotWithShape="1">
+          <a:gsLst>
+            <a:gs pos="0">
+              <a:schemeClr val="phClr">
+                <a:lumMod val="110000"/>
+                <a:satMod val="105000"/>
+                <a:tint val="67000"/>
+              </a:schemeClr>
+            </a:gs>
+            <a:gs pos="50000">
+              <a:schemeClr val="phClr">
+                <a:lumMod val="105000"/>
+                <a:satMod val="103000"/>
+                <a:tint val="73000"/>
+              </a:schemeClr>
+            </a:gs>
+            <a:gs pos="100000">
+              <a:schemeClr val="phClr">
+                <a:lumMod val="105000"/>
+                <a:satMod val="109000"/>
+                <a:tint val="81000"/>
+              </a:schemeClr>
+            </a:gs>
+          </a:gsLst>
+          <a:lin ang="5400000" scaled="0"/>
+        </a:gradFill>
+        <a:gradFill rotWithShape="1">
+          <a:gsLst>
+            <a:gs pos="0">
+              <a:schemeClr val="phClr">
+                <a:satMod val="103000"/>
+                <a:lumMod val="102000"/>
+                <a:tint val="94000"/>
+              </a:schemeClr>
+            </a:gs>
+            <a:gs pos="50000">
+              <a:schemeClr val="phClr">
+                <a:satMod val="110000"/>
+                <a:lumMod val="100000"/>
+                <a:shade val="100000"/>
+              </a:schemeClr>
+            </a:gs>
+            <a:gs pos="100000">
+              <a:schemeClr val="phClr">
+                <a:lumMod val="99000"/>
+                <a:satMod val="120000"/>
+                <a:shade val="78000"/>
+              </a:schemeClr>
+            </a:gs>
+          </a:gsLst>
+          <a:lin ang="5400000" scaled="0"/>
+        </a:gradFill>
+      </a:fillStyleLst>
+      <a:lnStyleLst>
+        <a:ln w="6350" cap="flat" cmpd="sng" algn="ctr">
+          <a:solidFill>
+            <a:schemeClr val="phClr"/>
+          </a:solidFill>
+          <a:prstDash val="solid"/>
+          <a:miter lim="800000"/>
+        </a:ln>
+        <a:ln w="12700" cap="flat" cmpd="sng" algn="ctr">
+          <a:solidFill>
+            <a:schemeClr val="phClr"/>
+          </a:solidFill>
+          <a:prstDash val="solid"/>
+          <a:miter lim="800000"/>
+        </a:ln>
+        <a:ln w="19050" cap="flat" cmpd="sng" algn="ctr">
+          <a:solidFill>
+            <a:schemeClr val="phClr"/>
+          </a:solidFill>
+          <a:prstDash val="solid"/>
+          <a:miter lim="800000"/>
+        </a:ln>
+      </a:lnStyleLst>
+      <a:effectStyleLst>
+        <a:effectStyle>
+          <a:effectLst/>
+        </a:effectStyle>
+        <a:effectStyle>
+          <a:effectLst/>
+        </a:effectStyle>
+        <a:effectStyle>
+          <a:effectLst>
+            <a:outerShdw blurRad="57150" dist="19050" dir="5400000" algn="ctr" rotWithShape="0">
+              <a:srgbClr val="000000">
+                <a:alpha val="63000"/>
+              </a:srgbClr>
+            </a:outerShdw>
+          </a:effectLst>
+        </a:effectStyle>
+      </a:effectStyleLst>
+      <a:bgFillStyleLst>
+        <a:solidFill>
+          <a:schemeClr val="phClr"/>
+        </a:solidFill>
+        <a:solidFill>
+          <a:schemeClr val="phClr">
+            <a:tint val="95000"/>
+            <a:satMod val="170000"/>
+          </a:schemeClr>
+        </a:solidFill>
+        <a:gradFill rotWithShape="1">
+          <a:gsLst>
+            <a:gs pos="0">
+              <a:schemeClr val="phClr">
+                <a:tint val="93000"/>
+                <a:satMod val="150000"/>
+                <a:shade val="98000"/>
+                <a:lumMod val="102000"/>
+              </a:schemeClr>
+            </a:gs>
+            <a:gs pos="50000">
+              <a:schemeClr val="phClr">
+                <a:tint val="98000"/>
+                <a:satMod val="130000"/>
+                <a:shade val="90000"/>
+                <a:lumMod val="103000"/>
+              </a:schemeClr>
+            </a:gs>
+            <a:gs pos="100000">
+              <a:schemeClr val="phClr">
+                <a:shade val="63000"/>
+                <a:satMod val="120000"/>
+              </a:schemeClr>
+            </a:gs>
+          </a:gsLst>
+          <a:lin ang="5400000" scaled="0"/>
+        </a:gradFill>
+      </a:bgFillStyleLst>
+    </a:fmtScheme>
+  </a:themeElements>
+  <a:objectDefaults/>
+  <a:extraClrSchemeLst/>
+  <a:extLst>
+    <a:ext uri="{05A4C25C-085E-4340-85A3-A5531E510DB2}">
+      <thm15:themeFamily xmlns:thm15="http://schemas.microsoft.com/office/thememl/2012/main" name="Office Theme" id="{62F939B6-93AF-4DB8-9C6B-D6C7DFDC589F}" vid="{4A3C46E8-61CC-4603-A589-7422A47A8E4A}"/>
+    </a:ext>
+  </a:extLst>
+</a:theme>
 </file>
</xml_diff>

<commit_message>
Instawards sprint proposal and community deck update
Spanish one-sprint proposal (MD + branded PDF) for the Stellar Instawards call: WattNode v0, P1-P4 priorities, 4-week timeline, ~$900 hardware budget from real Chilean price data. The community deck grows to 17 slides: WattNode architecture diagram, August 2026 status, and the sprint ask - validated by opening in PowerPoint.

Co-Authored-By: Claude Fable 5 <noreply@anthropic.com>
</commit_message>
<xml_diff>
--- a/docs/QWATT-stellar-community.pptx
+++ b/docs/QWATT-stellar-community.pptx
@@ -14,13 +14,16 @@
     <p:sldId id="259" r:id="rId5"/>
     <p:sldId id="260" r:id="rId6"/>
     <p:sldId id="261" r:id="rId7"/>
+    <p:sldId id="270" r:id="rId21"/>
     <p:sldId id="262" r:id="rId8"/>
+    <p:sldId id="271" r:id="rId22"/>
     <p:sldId id="263" r:id="rId9"/>
     <p:sldId id="264" r:id="rId10"/>
     <p:sldId id="265" r:id="rId11"/>
     <p:sldId id="266" r:id="rId12"/>
     <p:sldId id="267" r:id="rId13"/>
     <p:sldId id="268" r:id="rId14"/>
+    <p:sldId id="272" r:id="rId23"/>
     <p:sldId id="269" r:id="rId15"/>
   </p:sldIdLst>
   <p:sldSz cx="12192000" cy="6858000"/>
@@ -5349,6 +5352,2043 @@
               <a:t>Everything runs on Stellar testnet. Nothing here is an offer of securities or investment advice; QWATT is not for sale. Legal review precedes any mainnet or commercial step.</a:t>
             </a:r>
             <a:endParaRPr lang="en-US" sz="950" dirty="0"/>
+          </a:p>
+        </p:txBody>
+      </p:sp>
+    </p:spTree>
+  </p:cSld>
+  <p:clrMapOvr>
+    <a:masterClrMapping/>
+  </p:clrMapOvr>
+</p:sld>
+</file>
+
+<file path=ppt/slides/slide15.xml><?xml version="1.0" encoding="utf-8"?>
+<p:sld xmlns:a="http://schemas.openxmlformats.org/drawingml/2006/main" xmlns:r="http://schemas.openxmlformats.org/officeDocument/2006/relationships" xmlns:p="http://schemas.openxmlformats.org/presentationml/2006/main">
+  <p:cSld name="WattNode architecture">
+    <p:bg>
+      <p:bgPr>
+        <a:solidFill>
+          <a:srgbClr val="16100A"/>
+        </a:solidFill>
+        <a:effectLst/>
+      </p:bgPr>
+    </p:bg>
+    <p:spTree>
+      <p:nvGrpSpPr>
+        <p:cNvPr id="1" name=""/>
+        <p:cNvGrpSpPr/>
+        <p:nvPr/>
+      </p:nvGrpSpPr>
+      <p:grpSpPr>
+        <a:xfrm>
+          <a:off x="0" y="0"/>
+          <a:ext cx="0" cy="0"/>
+          <a:chOff x="0" y="0"/>
+          <a:chExt cx="0" cy="0"/>
+        </a:xfrm>
+      </p:grpSpPr>
+      <p:sp>
+        <p:nvSpPr>
+          <p:cNvPr id="2" name="Text"/>
+          <p:cNvSpPr/>
+          <p:nvPr/>
+        </p:nvSpPr>
+        <p:spPr>
+          <a:xfrm>
+            <a:off x="548640" y="6473952"/>
+            <a:ext cx="2286000" cy="274320"/>
+          </a:xfrm>
+          <a:prstGeom prst="rect">
+            <a:avLst/>
+          </a:prstGeom>
+          <a:noFill/>
+          <a:ln/>
+        </p:spPr>
+        <p:txBody>
+          <a:bodyPr wrap="square" lIns="0" tIns="0" rIns="0" bIns="0" rtlCol="0" anchor="ctr"/>
+          <a:lstStyle/>
+          <a:p>
+            <a:pPr marL="0" indent="0">
+              <a:buNone/>
+            </a:pPr>
+            <a:r>
+              <a:rPr lang="en-US" sz="1000" b="1" dirty="0">
+                <a:solidFill>
+                  <a:srgbClr val="8B7A64"/>
+                </a:solidFill>
+                <a:latin typeface="Courier New" pitchFamily="34" charset="0"/>
+                <a:ea typeface="Courier New" pitchFamily="34" charset="-122"/>
+                <a:cs typeface="Courier New" pitchFamily="34" charset="-120"/>
+              </a:rPr>
+              <a:t>⚡ QWATT</a:t>
+            </a:r>
+            <a:endParaRPr lang="en-US" sz="1000" dirty="0"/>
+          </a:p>
+        </p:txBody>
+      </p:sp>
+      <p:sp>
+        <p:nvSpPr>
+          <p:cNvPr id="3" name="Text"/>
+          <p:cNvSpPr/>
+          <p:nvPr/>
+        </p:nvSpPr>
+        <p:spPr>
+          <a:xfrm>
+            <a:off x="7525512" y="6473952"/>
+            <a:ext cx="4114800" cy="274320"/>
+          </a:xfrm>
+          <a:prstGeom prst="rect">
+            <a:avLst/>
+          </a:prstGeom>
+          <a:noFill/>
+          <a:ln/>
+        </p:spPr>
+        <p:txBody>
+          <a:bodyPr wrap="square" lIns="0" tIns="0" rIns="0" bIns="0" rtlCol="0" anchor="ctr"/>
+          <a:lstStyle/>
+          <a:p>
+            <a:pPr marL="0" indent="0" algn="r">
+              <a:buNone/>
+            </a:pPr>
+            <a:r>
+              <a:rPr lang="en-US" sz="900" dirty="0">
+                <a:solidFill>
+                  <a:srgbClr val="8B7A64"/>
+                </a:solidFill>
+                <a:latin typeface="Courier New" pitchFamily="34" charset="0"/>
+                <a:ea typeface="Courier New" pitchFamily="34" charset="-122"/>
+                <a:cs typeface="Courier New" pitchFamily="34" charset="-120"/>
+              </a:rPr>
+              <a:t>The Clean Token · qwatt.org</a:t>
+            </a:r>
+            <a:endParaRPr lang="en-US" sz="900" dirty="0"/>
+          </a:p>
+        </p:txBody>
+      </p:sp>
+      <p:sp>
+        <p:nvSpPr>
+          <p:cNvPr id="4" name="Text"/>
+          <p:cNvSpPr/>
+          <p:nvPr/>
+        </p:nvSpPr>
+        <p:spPr>
+          <a:xfrm>
+            <a:off x="548640" y="384048"/>
+            <a:ext cx="11091672" cy="274320"/>
+          </a:xfrm>
+          <a:prstGeom prst="rect">
+            <a:avLst/>
+          </a:prstGeom>
+          <a:noFill/>
+          <a:ln/>
+        </p:spPr>
+        <p:txBody>
+          <a:bodyPr wrap="square" lIns="0" tIns="0" rIns="0" bIns="0" rtlCol="0" anchor="ctr"/>
+          <a:lstStyle/>
+          <a:p>
+            <a:pPr marL="0" indent="0">
+              <a:buNone/>
+            </a:pPr>
+            <a:r>
+              <a:rPr lang="en-US" sz="1100" b="1" spc="300" kern="0" dirty="0">
+                <a:solidFill>
+                  <a:srgbClr val="D08A57"/>
+                </a:solidFill>
+                <a:latin typeface="Courier New" pitchFamily="34" charset="0"/>
+                <a:ea typeface="Courier New" pitchFamily="34" charset="-122"/>
+                <a:cs typeface="Courier New" pitchFamily="34" charset="-120"/>
+              </a:rPr>
+              <a:t>WATTNODE ARCHITECTURE</a:t>
+            </a:r>
+            <a:endParaRPr lang="en-US" sz="1100" dirty="0"/>
+          </a:p>
+        </p:txBody>
+      </p:sp>
+      <p:sp>
+        <p:nvSpPr>
+          <p:cNvPr id="5" name="Text"/>
+          <p:cNvSpPr/>
+          <p:nvPr/>
+        </p:nvSpPr>
+        <p:spPr>
+          <a:xfrm>
+            <a:off x="548640" y="658368"/>
+            <a:ext cx="11091672" cy="685800"/>
+          </a:xfrm>
+          <a:prstGeom prst="rect">
+            <a:avLst/>
+          </a:prstGeom>
+          <a:noFill/>
+          <a:ln/>
+        </p:spPr>
+        <p:txBody>
+          <a:bodyPr wrap="square" lIns="0" tIns="0" rIns="0" bIns="0" rtlCol="0" anchor="ctr"/>
+          <a:lstStyle/>
+          <a:p>
+            <a:pPr marL="0" indent="0">
+              <a:buNone/>
+            </a:pPr>
+            <a:r>
+              <a:rPr lang="en-US" sz="3000" b="1" dirty="0">
+                <a:solidFill>
+                  <a:srgbClr val="F0E8DC"/>
+                </a:solidFill>
+                <a:latin typeface="Arial" pitchFamily="34" charset="0"/>
+                <a:ea typeface="Arial" pitchFamily="34" charset="-122"/>
+                <a:cs typeface="Arial" pitchFamily="34" charset="-120"/>
+              </a:rPr>
+              <a:t>From panel to public ledger</a:t>
+            </a:r>
+            <a:endParaRPr lang="en-US" sz="3000" dirty="0"/>
+          </a:p>
+        </p:txBody>
+      </p:sp>
+      <p:pic>
+        <p:nvPicPr>
+          <p:cNvPr id="2" name="WattNode diagram"/>
+          <p:cNvPicPr>
+            <a:picLocks noChangeAspect="1"/>
+          </p:cNvPicPr>
+          <p:nvPr/>
+        </p:nvPicPr>
+        <p:blipFill>
+          <a:blip r:embed="rId2"/>
+          <a:stretch>
+            <a:fillRect/>
+          </a:stretch>
+        </p:blipFill>
+        <p:spPr>
+          <a:xfrm>
+            <a:off x="2516000" y="1481328"/>
+            <a:ext cx="7160000" cy="4858571"/>
+          </a:xfrm>
+          <a:prstGeom prst="rect">
+            <a:avLst/>
+          </a:prstGeom>
+        </p:spPr>
+      </p:pic>
+    </p:spTree>
+  </p:cSld>
+  <p:clrMapOvr>
+    <a:masterClrMapping/>
+  </p:clrMapOvr>
+</p:sld>
+</file>
+
+<file path=ppt/slides/slide16.xml><?xml version="1.0" encoding="utf-8"?>
+<p:sld xmlns:a="http://schemas.openxmlformats.org/drawingml/2006/main" xmlns:r="http://schemas.openxmlformats.org/officeDocument/2006/relationships" xmlns:p="http://schemas.openxmlformats.org/presentationml/2006/main">
+  <p:cSld name="Status August 2026">
+    <p:bg>
+      <p:bgPr>
+        <a:solidFill>
+          <a:srgbClr val="16100A"/>
+        </a:solidFill>
+        <a:effectLst/>
+      </p:bgPr>
+    </p:bg>
+    <p:spTree>
+      <p:nvGrpSpPr>
+        <p:cNvPr id="1" name=""/>
+        <p:cNvGrpSpPr/>
+        <p:nvPr/>
+      </p:nvGrpSpPr>
+      <p:grpSpPr>
+        <a:xfrm>
+          <a:off x="0" y="0"/>
+          <a:ext cx="0" cy="0"/>
+          <a:chOff x="0" y="0"/>
+          <a:chExt cx="0" cy="0"/>
+        </a:xfrm>
+      </p:grpSpPr>
+      <p:sp>
+        <p:nvSpPr>
+          <p:cNvPr id="2" name="Text"/>
+          <p:cNvSpPr/>
+          <p:nvPr/>
+        </p:nvSpPr>
+        <p:spPr>
+          <a:xfrm>
+            <a:off x="548640" y="6473952"/>
+            <a:ext cx="2286000" cy="274320"/>
+          </a:xfrm>
+          <a:prstGeom prst="rect">
+            <a:avLst/>
+          </a:prstGeom>
+          <a:noFill/>
+          <a:ln/>
+        </p:spPr>
+        <p:txBody>
+          <a:bodyPr wrap="square" lIns="0" tIns="0" rIns="0" bIns="0" rtlCol="0" anchor="ctr"/>
+          <a:lstStyle/>
+          <a:p>
+            <a:pPr marL="0" indent="0">
+              <a:buNone/>
+            </a:pPr>
+            <a:r>
+              <a:rPr lang="en-US" sz="1000" b="1" dirty="0">
+                <a:solidFill>
+                  <a:srgbClr val="8B7A64"/>
+                </a:solidFill>
+                <a:latin typeface="Courier New" pitchFamily="34" charset="0"/>
+                <a:ea typeface="Courier New" pitchFamily="34" charset="-122"/>
+                <a:cs typeface="Courier New" pitchFamily="34" charset="-120"/>
+              </a:rPr>
+              <a:t>⚡ QWATT</a:t>
+            </a:r>
+            <a:endParaRPr lang="en-US" sz="1000" dirty="0"/>
+          </a:p>
+        </p:txBody>
+      </p:sp>
+      <p:sp>
+        <p:nvSpPr>
+          <p:cNvPr id="3" name="Text"/>
+          <p:cNvSpPr/>
+          <p:nvPr/>
+        </p:nvSpPr>
+        <p:spPr>
+          <a:xfrm>
+            <a:off x="7525512" y="6473952"/>
+            <a:ext cx="4114800" cy="274320"/>
+          </a:xfrm>
+          <a:prstGeom prst="rect">
+            <a:avLst/>
+          </a:prstGeom>
+          <a:noFill/>
+          <a:ln/>
+        </p:spPr>
+        <p:txBody>
+          <a:bodyPr wrap="square" lIns="0" tIns="0" rIns="0" bIns="0" rtlCol="0" anchor="ctr"/>
+          <a:lstStyle/>
+          <a:p>
+            <a:pPr marL="0" indent="0" algn="r">
+              <a:buNone/>
+            </a:pPr>
+            <a:r>
+              <a:rPr lang="en-US" sz="900" dirty="0">
+                <a:solidFill>
+                  <a:srgbClr val="8B7A64"/>
+                </a:solidFill>
+                <a:latin typeface="Courier New" pitchFamily="34" charset="0"/>
+                <a:ea typeface="Courier New" pitchFamily="34" charset="-122"/>
+                <a:cs typeface="Courier New" pitchFamily="34" charset="-120"/>
+              </a:rPr>
+              <a:t>The Clean Token · qwatt.org</a:t>
+            </a:r>
+            <a:endParaRPr lang="en-US" sz="900" dirty="0"/>
+          </a:p>
+        </p:txBody>
+      </p:sp>
+      <p:sp>
+        <p:nvSpPr>
+          <p:cNvPr id="4" name="Text"/>
+          <p:cNvSpPr/>
+          <p:nvPr/>
+        </p:nvSpPr>
+        <p:spPr>
+          <a:xfrm>
+            <a:off x="548640" y="384048"/>
+            <a:ext cx="11091672" cy="274320"/>
+          </a:xfrm>
+          <a:prstGeom prst="rect">
+            <a:avLst/>
+          </a:prstGeom>
+          <a:noFill/>
+          <a:ln/>
+        </p:spPr>
+        <p:txBody>
+          <a:bodyPr wrap="square" lIns="0" tIns="0" rIns="0" bIns="0" rtlCol="0" anchor="ctr"/>
+          <a:lstStyle/>
+          <a:p>
+            <a:pPr marL="0" indent="0">
+              <a:buNone/>
+            </a:pPr>
+            <a:r>
+              <a:rPr lang="en-US" sz="1100" b="1" spc="300" kern="0" dirty="0">
+                <a:solidFill>
+                  <a:srgbClr val="D08A57"/>
+                </a:solidFill>
+                <a:latin typeface="Courier New" pitchFamily="34" charset="0"/>
+                <a:ea typeface="Courier New" pitchFamily="34" charset="-122"/>
+                <a:cs typeface="Courier New" pitchFamily="34" charset="-120"/>
+              </a:rPr>
+              <a:t>STATUS — AUGUST 2026</a:t>
+            </a:r>
+            <a:endParaRPr lang="en-US" sz="1100" dirty="0"/>
+          </a:p>
+        </p:txBody>
+      </p:sp>
+      <p:sp>
+        <p:nvSpPr>
+          <p:cNvPr id="5" name="Text"/>
+          <p:cNvSpPr/>
+          <p:nvPr/>
+        </p:nvSpPr>
+        <p:spPr>
+          <a:xfrm>
+            <a:off x="548640" y="658368"/>
+            <a:ext cx="11091672" cy="685800"/>
+          </a:xfrm>
+          <a:prstGeom prst="rect">
+            <a:avLst/>
+          </a:prstGeom>
+          <a:noFill/>
+          <a:ln/>
+        </p:spPr>
+        <p:txBody>
+          <a:bodyPr wrap="square" lIns="0" tIns="0" rIns="0" bIns="0" rtlCol="0" anchor="ctr"/>
+          <a:lstStyle/>
+          <a:p>
+            <a:pPr marL="0" indent="0">
+              <a:buNone/>
+            </a:pPr>
+            <a:r>
+              <a:rPr lang="en-US" sz="3000" b="1" dirty="0">
+                <a:solidFill>
+                  <a:srgbClr val="F0E8DC"/>
+                </a:solidFill>
+                <a:latin typeface="Arial" pitchFamily="34" charset="0"/>
+                <a:ea typeface="Arial" pitchFamily="34" charset="-122"/>
+                <a:cs typeface="Arial" pitchFamily="34" charset="-120"/>
+              </a:rPr>
+              <a:t>Shipped since the hackathon</a:t>
+            </a:r>
+            <a:endParaRPr lang="en-US" sz="3000" dirty="0"/>
+          </a:p>
+        </p:txBody>
+      </p:sp>
+      <p:sp>
+        <p:nvSpPr>
+          <p:cNvPr id="6" name="Card"/>
+          <p:cNvSpPr/>
+          <p:nvPr/>
+        </p:nvSpPr>
+        <p:spPr>
+          <a:xfrm>
+            <a:off x="548640" y="1691640"/>
+            <a:ext cx="5362956" cy="1417320"/>
+          </a:xfrm>
+          <a:prstGeom prst="roundRect">
+            <a:avLst>
+              <a:gd name="adj" fmla="val 3871"/>
+            </a:avLst>
+          </a:prstGeom>
+          <a:solidFill>
+            <a:srgbClr val="231A10"/>
+          </a:solidFill>
+          <a:ln w="12700">
+            <a:solidFill>
+              <a:srgbClr val="3B2D1D"/>
+            </a:solidFill>
+            <a:prstDash val="solid"/>
+          </a:ln>
+        </p:spPr>
+      </p:sp>
+      <p:sp>
+        <p:nvSpPr>
+          <p:cNvPr id="7" name="Text"/>
+          <p:cNvSpPr/>
+          <p:nvPr/>
+        </p:nvSpPr>
+        <p:spPr>
+          <a:xfrm>
+            <a:off x="777240" y="1828800"/>
+            <a:ext cx="3717036" cy="320040"/>
+          </a:xfrm>
+          <a:prstGeom prst="rect">
+            <a:avLst/>
+          </a:prstGeom>
+          <a:noFill/>
+          <a:ln/>
+        </p:spPr>
+        <p:txBody>
+          <a:bodyPr wrap="square" lIns="0" tIns="0" rIns="0" bIns="0" rtlCol="0" anchor="ctr"/>
+          <a:lstStyle/>
+          <a:p>
+            <a:pPr marL="0" indent="0">
+              <a:buNone/>
+            </a:pPr>
+            <a:r>
+              <a:rPr lang="en-US" sz="1500" b="1" dirty="0">
+                <a:solidFill>
+                  <a:srgbClr val="F0E8DC"/>
+                </a:solidFill>
+                <a:latin typeface="Arial" pitchFamily="34" charset="0"/>
+                <a:ea typeface="Arial" pitchFamily="34" charset="-122"/>
+                <a:cs typeface="Arial" pitchFamily="34" charset="-120"/>
+              </a:rPr>
+              <a:t>Brand + product</a:t>
+            </a:r>
+            <a:endParaRPr lang="en-US" sz="1500" dirty="0"/>
+          </a:p>
+        </p:txBody>
+      </p:sp>
+      <p:sp>
+        <p:nvSpPr>
+          <p:cNvPr id="8" name="Chip"/>
+          <p:cNvSpPr/>
+          <p:nvPr/>
+        </p:nvSpPr>
+        <p:spPr>
+          <a:xfrm>
+            <a:off x="4585716" y="1856232"/>
+            <a:ext cx="1097280" cy="237744"/>
+          </a:xfrm>
+          <a:prstGeom prst="roundRect">
+            <a:avLst>
+              <a:gd name="adj" fmla="val 50000"/>
+            </a:avLst>
+          </a:prstGeom>
+          <a:solidFill>
+            <a:srgbClr val="16100A"/>
+          </a:solidFill>
+          <a:ln w="12700">
+            <a:solidFill>
+              <a:srgbClr val="3CB87F"/>
+            </a:solidFill>
+            <a:prstDash val="solid"/>
+          </a:ln>
+        </p:spPr>
+      </p:sp>
+      <p:sp>
+        <p:nvSpPr>
+          <p:cNvPr id="9" name="Text"/>
+          <p:cNvSpPr/>
+          <p:nvPr/>
+        </p:nvSpPr>
+        <p:spPr>
+          <a:xfrm>
+            <a:off x="4585716" y="1848917"/>
+            <a:ext cx="1097280" cy="256032"/>
+          </a:xfrm>
+          <a:prstGeom prst="rect">
+            <a:avLst/>
+          </a:prstGeom>
+          <a:noFill/>
+          <a:ln/>
+        </p:spPr>
+        <p:txBody>
+          <a:bodyPr wrap="square" lIns="0" tIns="0" rIns="0" bIns="0" rtlCol="0" anchor="ctr"/>
+          <a:lstStyle/>
+          <a:p>
+            <a:pPr marL="0" indent="0" algn="ctr">
+              <a:buNone/>
+            </a:pPr>
+            <a:r>
+              <a:rPr lang="en-US" sz="850" b="1" dirty="0">
+                <a:solidFill>
+                  <a:srgbClr val="3CB87F"/>
+                </a:solidFill>
+                <a:latin typeface="Courier New" pitchFamily="34" charset="0"/>
+                <a:ea typeface="Courier New" pitchFamily="34" charset="-122"/>
+                <a:cs typeface="Courier New" pitchFamily="34" charset="-120"/>
+              </a:rPr>
+              <a:t>● LIVE</a:t>
+            </a:r>
+            <a:endParaRPr lang="en-US" sz="850" dirty="0"/>
+          </a:p>
+        </p:txBody>
+      </p:sp>
+      <p:sp>
+        <p:nvSpPr>
+          <p:cNvPr id="10" name="Text"/>
+          <p:cNvSpPr/>
+          <p:nvPr/>
+        </p:nvSpPr>
+        <p:spPr>
+          <a:xfrm>
+            <a:off x="777240" y="2221992"/>
+            <a:ext cx="4905756" cy="777240"/>
+          </a:xfrm>
+          <a:prstGeom prst="rect">
+            <a:avLst/>
+          </a:prstGeom>
+          <a:noFill/>
+          <a:ln/>
+        </p:spPr>
+        <p:txBody>
+          <a:bodyPr wrap="square" lIns="0" tIns="0" rIns="0" bIns="0" rtlCol="0" anchor="ctr"/>
+          <a:lstStyle/>
+          <a:p>
+            <a:pPr marL="0" indent="0">
+              <a:buNone/>
+            </a:pPr>
+            <a:r>
+              <a:rPr lang="en-US" sz="1150" dirty="0">
+                <a:solidFill>
+                  <a:srgbClr val="B3A48F"/>
+                </a:solidFill>
+                <a:latin typeface="Arial" pitchFamily="34" charset="0"/>
+                <a:ea typeface="Arial" pitchFamily="34" charset="-122"/>
+                <a:cs typeface="Arial" pitchFamily="34" charset="-120"/>
+              </a:rPr>
+              <a:t>Q-ring identity, day/night editorial UI, status-dot navigation — Lighthouse 100 accessibility, 100 best practices, 100 SEO</a:t>
+            </a:r>
+            <a:endParaRPr lang="en-US" sz="1150" dirty="0"/>
+          </a:p>
+        </p:txBody>
+      </p:sp>
+      <p:sp>
+        <p:nvSpPr>
+          <p:cNvPr id="11" name="Card"/>
+          <p:cNvSpPr/>
+          <p:nvPr/>
+        </p:nvSpPr>
+        <p:spPr>
+          <a:xfrm>
+            <a:off x="6277356" y="1691640"/>
+            <a:ext cx="5362956" cy="1417320"/>
+          </a:xfrm>
+          <a:prstGeom prst="roundRect">
+            <a:avLst>
+              <a:gd name="adj" fmla="val 3871"/>
+            </a:avLst>
+          </a:prstGeom>
+          <a:solidFill>
+            <a:srgbClr val="231A10"/>
+          </a:solidFill>
+          <a:ln w="12700">
+            <a:solidFill>
+              <a:srgbClr val="3B2D1D"/>
+            </a:solidFill>
+            <a:prstDash val="solid"/>
+          </a:ln>
+        </p:spPr>
+      </p:sp>
+      <p:sp>
+        <p:nvSpPr>
+          <p:cNvPr id="12" name="Text"/>
+          <p:cNvSpPr/>
+          <p:nvPr/>
+        </p:nvSpPr>
+        <p:spPr>
+          <a:xfrm>
+            <a:off x="6505956" y="1828800"/>
+            <a:ext cx="3717036" cy="320040"/>
+          </a:xfrm>
+          <a:prstGeom prst="rect">
+            <a:avLst/>
+          </a:prstGeom>
+          <a:noFill/>
+          <a:ln/>
+        </p:spPr>
+        <p:txBody>
+          <a:bodyPr wrap="square" lIns="0" tIns="0" rIns="0" bIns="0" rtlCol="0" anchor="ctr"/>
+          <a:lstStyle/>
+          <a:p>
+            <a:pPr marL="0" indent="0">
+              <a:buNone/>
+            </a:pPr>
+            <a:r>
+              <a:rPr lang="en-US" sz="1500" b="1" dirty="0">
+                <a:solidFill>
+                  <a:srgbClr val="F0E8DC"/>
+                </a:solidFill>
+                <a:latin typeface="Arial" pitchFamily="34" charset="0"/>
+                <a:ea typeface="Arial" pitchFamily="34" charset="-122"/>
+                <a:cs typeface="Arial" pitchFamily="34" charset="-120"/>
+              </a:rPr>
+              <a:t>Growth stack</a:t>
+            </a:r>
+            <a:endParaRPr lang="en-US" sz="1500" dirty="0"/>
+          </a:p>
+        </p:txBody>
+      </p:sp>
+      <p:sp>
+        <p:nvSpPr>
+          <p:cNvPr id="13" name="Chip"/>
+          <p:cNvSpPr/>
+          <p:nvPr/>
+        </p:nvSpPr>
+        <p:spPr>
+          <a:xfrm>
+            <a:off x="10314432" y="1856232"/>
+            <a:ext cx="1097280" cy="237744"/>
+          </a:xfrm>
+          <a:prstGeom prst="roundRect">
+            <a:avLst>
+              <a:gd name="adj" fmla="val 50000"/>
+            </a:avLst>
+          </a:prstGeom>
+          <a:solidFill>
+            <a:srgbClr val="16100A"/>
+          </a:solidFill>
+          <a:ln w="12700">
+            <a:solidFill>
+              <a:srgbClr val="3CB87F"/>
+            </a:solidFill>
+            <a:prstDash val="solid"/>
+          </a:ln>
+        </p:spPr>
+      </p:sp>
+      <p:sp>
+        <p:nvSpPr>
+          <p:cNvPr id="14" name="Text"/>
+          <p:cNvSpPr/>
+          <p:nvPr/>
+        </p:nvSpPr>
+        <p:spPr>
+          <a:xfrm>
+            <a:off x="10314432" y="1848917"/>
+            <a:ext cx="1097280" cy="256032"/>
+          </a:xfrm>
+          <a:prstGeom prst="rect">
+            <a:avLst/>
+          </a:prstGeom>
+          <a:noFill/>
+          <a:ln/>
+        </p:spPr>
+        <p:txBody>
+          <a:bodyPr wrap="square" lIns="0" tIns="0" rIns="0" bIns="0" rtlCol="0" anchor="ctr"/>
+          <a:lstStyle/>
+          <a:p>
+            <a:pPr marL="0" indent="0" algn="ctr">
+              <a:buNone/>
+            </a:pPr>
+            <a:r>
+              <a:rPr lang="en-US" sz="850" b="1" dirty="0">
+                <a:solidFill>
+                  <a:srgbClr val="3CB87F"/>
+                </a:solidFill>
+                <a:latin typeface="Courier New" pitchFamily="34" charset="0"/>
+                <a:ea typeface="Courier New" pitchFamily="34" charset="-122"/>
+                <a:cs typeface="Courier New" pitchFamily="34" charset="-120"/>
+              </a:rPr>
+              <a:t>● LIVE</a:t>
+            </a:r>
+            <a:endParaRPr lang="en-US" sz="850" dirty="0"/>
+          </a:p>
+        </p:txBody>
+      </p:sp>
+      <p:sp>
+        <p:nvSpPr>
+          <p:cNvPr id="15" name="Text"/>
+          <p:cNvSpPr/>
+          <p:nvPr/>
+        </p:nvSpPr>
+        <p:spPr>
+          <a:xfrm>
+            <a:off x="6505956" y="2221992"/>
+            <a:ext cx="4905756" cy="777240"/>
+          </a:xfrm>
+          <a:prstGeom prst="rect">
+            <a:avLst/>
+          </a:prstGeom>
+          <a:noFill/>
+          <a:ln/>
+        </p:spPr>
+        <p:txBody>
+          <a:bodyPr wrap="square" lIns="0" tIns="0" rIns="0" bIns="0" rtlCol="0" anchor="ctr"/>
+          <a:lstStyle/>
+          <a:p>
+            <a:pPr marL="0" indent="0">
+              <a:buNone/>
+            </a:pPr>
+            <a:r>
+              <a:rPr lang="en-US" sz="1150" dirty="0">
+                <a:solidFill>
+                  <a:srgbClr val="B3A48F"/>
+                </a:solidFill>
+                <a:latin typeface="Arial" pitchFamily="34" charset="0"/>
+                <a:ea typeface="Arial" pitchFamily="34" charset="-122"/>
+                <a:cs typeface="Arial" pitchFamily="34" charset="-120"/>
+              </a:rPr>
+              <a:t>GA4 analytics · direct-contact form to the founders’ inbox · branded OG share cards · auto-deploys from GitHub</a:t>
+            </a:r>
+            <a:endParaRPr lang="en-US" sz="1150" dirty="0"/>
+          </a:p>
+        </p:txBody>
+      </p:sp>
+      <p:sp>
+        <p:nvSpPr>
+          <p:cNvPr id="16" name="Card"/>
+          <p:cNvSpPr/>
+          <p:nvPr/>
+        </p:nvSpPr>
+        <p:spPr>
+          <a:xfrm>
+            <a:off x="548640" y="3429000"/>
+            <a:ext cx="5362956" cy="1417320"/>
+          </a:xfrm>
+          <a:prstGeom prst="roundRect">
+            <a:avLst>
+              <a:gd name="adj" fmla="val 3871"/>
+            </a:avLst>
+          </a:prstGeom>
+          <a:solidFill>
+            <a:srgbClr val="231A10"/>
+          </a:solidFill>
+          <a:ln w="12700">
+            <a:solidFill>
+              <a:srgbClr val="3B2D1D"/>
+            </a:solidFill>
+            <a:prstDash val="solid"/>
+          </a:ln>
+        </p:spPr>
+      </p:sp>
+      <p:sp>
+        <p:nvSpPr>
+          <p:cNvPr id="17" name="Text"/>
+          <p:cNvSpPr/>
+          <p:nvPr/>
+        </p:nvSpPr>
+        <p:spPr>
+          <a:xfrm>
+            <a:off x="777240" y="3566160"/>
+            <a:ext cx="3717036" cy="320040"/>
+          </a:xfrm>
+          <a:prstGeom prst="rect">
+            <a:avLst/>
+          </a:prstGeom>
+          <a:noFill/>
+          <a:ln/>
+        </p:spPr>
+        <p:txBody>
+          <a:bodyPr wrap="square" lIns="0" tIns="0" rIns="0" bIns="0" rtlCol="0" anchor="ctr"/>
+          <a:lstStyle/>
+          <a:p>
+            <a:pPr marL="0" indent="0">
+              <a:buNone/>
+            </a:pPr>
+            <a:r>
+              <a:rPr lang="en-US" sz="1500" b="1" dirty="0">
+                <a:solidFill>
+                  <a:srgbClr val="F0E8DC"/>
+                </a:solidFill>
+                <a:latin typeface="Arial" pitchFamily="34" charset="0"/>
+                <a:ea typeface="Arial" pitchFamily="34" charset="-122"/>
+                <a:cs typeface="Arial" pitchFamily="34" charset="-120"/>
+              </a:rPr>
+              <a:t>Community</a:t>
+            </a:r>
+            <a:endParaRPr lang="en-US" sz="1500" dirty="0"/>
+          </a:p>
+        </p:txBody>
+      </p:sp>
+      <p:sp>
+        <p:nvSpPr>
+          <p:cNvPr id="18" name="Chip"/>
+          <p:cNvSpPr/>
+          <p:nvPr/>
+        </p:nvSpPr>
+        <p:spPr>
+          <a:xfrm>
+            <a:off x="4585716" y="3593592"/>
+            <a:ext cx="1097280" cy="237744"/>
+          </a:xfrm>
+          <a:prstGeom prst="roundRect">
+            <a:avLst>
+              <a:gd name="adj" fmla="val 50000"/>
+            </a:avLst>
+          </a:prstGeom>
+          <a:solidFill>
+            <a:srgbClr val="16100A"/>
+          </a:solidFill>
+          <a:ln w="12700">
+            <a:solidFill>
+              <a:srgbClr val="D9B26A"/>
+            </a:solidFill>
+            <a:prstDash val="solid"/>
+          </a:ln>
+        </p:spPr>
+      </p:sp>
+      <p:sp>
+        <p:nvSpPr>
+          <p:cNvPr id="19" name="Text"/>
+          <p:cNvSpPr/>
+          <p:nvPr/>
+        </p:nvSpPr>
+        <p:spPr>
+          <a:xfrm>
+            <a:off x="4585716" y="3586277"/>
+            <a:ext cx="1097280" cy="256032"/>
+          </a:xfrm>
+          <a:prstGeom prst="rect">
+            <a:avLst/>
+          </a:prstGeom>
+          <a:noFill/>
+          <a:ln/>
+        </p:spPr>
+        <p:txBody>
+          <a:bodyPr wrap="square" lIns="0" tIns="0" rIns="0" bIns="0" rtlCol="0" anchor="ctr"/>
+          <a:lstStyle/>
+          <a:p>
+            <a:pPr marL="0" indent="0" algn="ctr">
+              <a:buNone/>
+            </a:pPr>
+            <a:r>
+              <a:rPr lang="en-US" sz="850" b="1" dirty="0">
+                <a:solidFill>
+                  <a:srgbClr val="D9B26A"/>
+                </a:solidFill>
+                <a:latin typeface="Courier New" pitchFamily="34" charset="0"/>
+                <a:ea typeface="Courier New" pitchFamily="34" charset="-122"/>
+                <a:cs typeface="Courier New" pitchFamily="34" charset="-120"/>
+              </a:rPr>
+              <a:t>READY</a:t>
+            </a:r>
+            <a:endParaRPr lang="en-US" sz="850" dirty="0"/>
+          </a:p>
+        </p:txBody>
+      </p:sp>
+      <p:sp>
+        <p:nvSpPr>
+          <p:cNvPr id="20" name="Text"/>
+          <p:cNvSpPr/>
+          <p:nvPr/>
+        </p:nvSpPr>
+        <p:spPr>
+          <a:xfrm>
+            <a:off x="777240" y="3959352"/>
+            <a:ext cx="4905756" cy="777240"/>
+          </a:xfrm>
+          <a:prstGeom prst="rect">
+            <a:avLst/>
+          </a:prstGeom>
+          <a:noFill/>
+          <a:ln/>
+        </p:spPr>
+        <p:txBody>
+          <a:bodyPr wrap="square" lIns="0" tIns="0" rIns="0" bIns="0" rtlCol="0" anchor="ctr"/>
+          <a:lstStyle/>
+          <a:p>
+            <a:pPr marL="0" indent="0">
+              <a:buNone/>
+            </a:pPr>
+            <a:r>
+              <a:rPr lang="en-US" sz="1150" dirty="0">
+                <a:solidFill>
+                  <a:srgbClr val="B3A48F"/>
+                </a:solidFill>
+                <a:latin typeface="Arial" pitchFamily="34" charset="0"/>
+                <a:ea typeface="Arial" pitchFamily="34" charset="-122"/>
+                <a:cs typeface="Arial" pitchFamily="34" charset="-120"/>
+              </a:rPr>
+              <a:t>Bilingual launch kit: LinkedIn + X + promo art · Stellar Barrio: Instawards sprint call booked for the September round</a:t>
+            </a:r>
+            <a:endParaRPr lang="en-US" sz="1150" dirty="0"/>
+          </a:p>
+        </p:txBody>
+      </p:sp>
+      <p:sp>
+        <p:nvSpPr>
+          <p:cNvPr id="21" name="Card"/>
+          <p:cNvSpPr/>
+          <p:nvPr/>
+        </p:nvSpPr>
+        <p:spPr>
+          <a:xfrm>
+            <a:off x="6277356" y="3429000"/>
+            <a:ext cx="5362956" cy="1417320"/>
+          </a:xfrm>
+          <a:prstGeom prst="roundRect">
+            <a:avLst>
+              <a:gd name="adj" fmla="val 3871"/>
+            </a:avLst>
+          </a:prstGeom>
+          <a:solidFill>
+            <a:srgbClr val="231A10"/>
+          </a:solidFill>
+          <a:ln w="12700">
+            <a:solidFill>
+              <a:srgbClr val="3B2D1D"/>
+            </a:solidFill>
+            <a:prstDash val="solid"/>
+          </a:ln>
+        </p:spPr>
+      </p:sp>
+      <p:sp>
+        <p:nvSpPr>
+          <p:cNvPr id="22" name="Text"/>
+          <p:cNvSpPr/>
+          <p:nvPr/>
+        </p:nvSpPr>
+        <p:spPr>
+          <a:xfrm>
+            <a:off x="6505956" y="3566160"/>
+            <a:ext cx="3717036" cy="320040"/>
+          </a:xfrm>
+          <a:prstGeom prst="rect">
+            <a:avLst/>
+          </a:prstGeom>
+          <a:noFill/>
+          <a:ln/>
+        </p:spPr>
+        <p:txBody>
+          <a:bodyPr wrap="square" lIns="0" tIns="0" rIns="0" bIns="0" rtlCol="0" anchor="ctr"/>
+          <a:lstStyle/>
+          <a:p>
+            <a:pPr marL="0" indent="0">
+              <a:buNone/>
+            </a:pPr>
+            <a:r>
+              <a:rPr lang="en-US" sz="1500" b="1" dirty="0">
+                <a:solidFill>
+                  <a:srgbClr val="F0E8DC"/>
+                </a:solidFill>
+                <a:latin typeface="Arial" pitchFamily="34" charset="0"/>
+                <a:ea typeface="Arial" pitchFamily="34" charset="-122"/>
+                <a:cs typeface="Arial" pitchFamily="34" charset="-120"/>
+              </a:rPr>
+              <a:t>Next unlock</a:t>
+            </a:r>
+            <a:endParaRPr lang="en-US" sz="1500" dirty="0"/>
+          </a:p>
+        </p:txBody>
+      </p:sp>
+      <p:sp>
+        <p:nvSpPr>
+          <p:cNvPr id="23" name="Chip"/>
+          <p:cNvSpPr/>
+          <p:nvPr/>
+        </p:nvSpPr>
+        <p:spPr>
+          <a:xfrm>
+            <a:off x="10314432" y="3593592"/>
+            <a:ext cx="1097280" cy="237744"/>
+          </a:xfrm>
+          <a:prstGeom prst="roundRect">
+            <a:avLst>
+              <a:gd name="adj" fmla="val 50000"/>
+            </a:avLst>
+          </a:prstGeom>
+          <a:solidFill>
+            <a:srgbClr val="16100A"/>
+          </a:solidFill>
+          <a:ln w="12700">
+            <a:solidFill>
+              <a:srgbClr val="D9B26A"/>
+            </a:solidFill>
+            <a:prstDash val="solid"/>
+          </a:ln>
+        </p:spPr>
+      </p:sp>
+      <p:sp>
+        <p:nvSpPr>
+          <p:cNvPr id="24" name="Text"/>
+          <p:cNvSpPr/>
+          <p:nvPr/>
+        </p:nvSpPr>
+        <p:spPr>
+          <a:xfrm>
+            <a:off x="10314432" y="3586277"/>
+            <a:ext cx="1097280" cy="256032"/>
+          </a:xfrm>
+          <a:prstGeom prst="rect">
+            <a:avLst/>
+          </a:prstGeom>
+          <a:noFill/>
+          <a:ln/>
+        </p:spPr>
+        <p:txBody>
+          <a:bodyPr wrap="square" lIns="0" tIns="0" rIns="0" bIns="0" rtlCol="0" anchor="ctr"/>
+          <a:lstStyle/>
+          <a:p>
+            <a:pPr marL="0" indent="0" algn="ctr">
+              <a:buNone/>
+            </a:pPr>
+            <a:r>
+              <a:rPr lang="en-US" sz="850" b="1" dirty="0">
+                <a:solidFill>
+                  <a:srgbClr val="D9B26A"/>
+                </a:solidFill>
+                <a:latin typeface="Courier New" pitchFamily="34" charset="0"/>
+                <a:ea typeface="Courier New" pitchFamily="34" charset="-122"/>
+                <a:cs typeface="Courier New" pitchFamily="34" charset="-120"/>
+              </a:rPr>
+              <a:t>PENDING</a:t>
+            </a:r>
+            <a:endParaRPr lang="en-US" sz="850" dirty="0"/>
+          </a:p>
+        </p:txBody>
+      </p:sp>
+      <p:sp>
+        <p:nvSpPr>
+          <p:cNvPr id="25" name="Text"/>
+          <p:cNvSpPr/>
+          <p:nvPr/>
+        </p:nvSpPr>
+        <p:spPr>
+          <a:xfrm>
+            <a:off x="6505956" y="3959352"/>
+            <a:ext cx="4905756" cy="777240"/>
+          </a:xfrm>
+          <a:prstGeom prst="rect">
+            <a:avLst/>
+          </a:prstGeom>
+          <a:noFill/>
+          <a:ln/>
+        </p:spPr>
+        <p:txBody>
+          <a:bodyPr wrap="square" lIns="0" tIns="0" rIns="0" bIns="0" rtlCol="0" anchor="ctr"/>
+          <a:lstStyle/>
+          <a:p>
+            <a:pPr marL="0" indent="0">
+              <a:buNone/>
+            </a:pPr>
+            <a:r>
+              <a:rPr lang="en-US" sz="1150" dirty="0">
+                <a:solidFill>
+                  <a:srgbClr val="B3A48F"/>
+                </a:solidFill>
+                <a:latin typeface="Arial" pitchFamily="34" charset="0"/>
+                <a:ea typeface="Arial" pitchFamily="34" charset="-122"/>
+                <a:cs typeface="Arial" pitchFamily="34" charset="-120"/>
+              </a:rPr>
+              <a:t>First real PoG event — QW-000001 in the Explorer · home_domain so wallets read the asset’s stellar.toml brand</a:t>
+            </a:r>
+            <a:endParaRPr lang="en-US" sz="1150" dirty="0"/>
+          </a:p>
+        </p:txBody>
+      </p:sp>
+      <p:sp>
+        <p:nvSpPr>
+          <p:cNvPr id="26" name="Text"/>
+          <p:cNvSpPr/>
+          <p:nvPr/>
+        </p:nvSpPr>
+        <p:spPr>
+          <a:xfrm>
+            <a:off x="548640" y="5349240"/>
+            <a:ext cx="11091672" cy="274320"/>
+          </a:xfrm>
+          <a:prstGeom prst="rect">
+            <a:avLst/>
+          </a:prstGeom>
+          <a:noFill/>
+          <a:ln/>
+        </p:spPr>
+        <p:txBody>
+          <a:bodyPr wrap="square" lIns="0" tIns="0" rIns="0" bIns="0" rtlCol="0" anchor="ctr"/>
+          <a:lstStyle/>
+          <a:p>
+            <a:pPr marL="0" indent="0" algn="ctr">
+              <a:buNone/>
+            </a:pPr>
+            <a:r>
+              <a:rPr lang="en-US" sz="1250" dirty="0">
+                <a:solidFill>
+                  <a:srgbClr val="D9B26A"/>
+                </a:solidFill>
+                <a:latin typeface="Arial" pitchFamily="34" charset="0"/>
+                <a:ea typeface="Arial" pitchFamily="34" charset="-122"/>
+                <a:cs typeface="Arial" pitchFamily="34" charset="-120"/>
+              </a:rPr>
+              <a:t>Four days from hackathon demo to a branded, measured, launch-ready protocol site.</a:t>
+            </a:r>
+            <a:endParaRPr lang="en-US" sz="1250" dirty="0"/>
+          </a:p>
+        </p:txBody>
+      </p:sp>
+    </p:spTree>
+  </p:cSld>
+  <p:clrMapOvr>
+    <a:masterClrMapping/>
+  </p:clrMapOvr>
+</p:sld>
+</file>
+
+<file path=ppt/slides/slide17.xml><?xml version="1.0" encoding="utf-8"?>
+<p:sld xmlns:a="http://schemas.openxmlformats.org/drawingml/2006/main" xmlns:r="http://schemas.openxmlformats.org/officeDocument/2006/relationships" xmlns:p="http://schemas.openxmlformats.org/presentationml/2006/main">
+  <p:cSld name="Instawards sprint">
+    <p:bg>
+      <p:bgPr>
+        <a:solidFill>
+          <a:srgbClr val="16100A"/>
+        </a:solidFill>
+        <a:effectLst/>
+      </p:bgPr>
+    </p:bg>
+    <p:spTree>
+      <p:nvGrpSpPr>
+        <p:cNvPr id="1" name=""/>
+        <p:cNvGrpSpPr/>
+        <p:nvPr/>
+      </p:nvGrpSpPr>
+      <p:grpSpPr>
+        <a:xfrm>
+          <a:off x="0" y="0"/>
+          <a:ext cx="0" cy="0"/>
+          <a:chOff x="0" y="0"/>
+          <a:chExt cx="0" cy="0"/>
+        </a:xfrm>
+      </p:grpSpPr>
+      <p:sp>
+        <p:nvSpPr>
+          <p:cNvPr id="2" name="Text"/>
+          <p:cNvSpPr/>
+          <p:nvPr/>
+        </p:nvSpPr>
+        <p:spPr>
+          <a:xfrm>
+            <a:off x="548640" y="6473952"/>
+            <a:ext cx="2286000" cy="274320"/>
+          </a:xfrm>
+          <a:prstGeom prst="rect">
+            <a:avLst/>
+          </a:prstGeom>
+          <a:noFill/>
+          <a:ln/>
+        </p:spPr>
+        <p:txBody>
+          <a:bodyPr wrap="square" lIns="0" tIns="0" rIns="0" bIns="0" rtlCol="0" anchor="ctr"/>
+          <a:lstStyle/>
+          <a:p>
+            <a:pPr marL="0" indent="0">
+              <a:buNone/>
+            </a:pPr>
+            <a:r>
+              <a:rPr lang="en-US" sz="1000" b="1" dirty="0">
+                <a:solidFill>
+                  <a:srgbClr val="8B7A64"/>
+                </a:solidFill>
+                <a:latin typeface="Courier New" pitchFamily="34" charset="0"/>
+                <a:ea typeface="Courier New" pitchFamily="34" charset="-122"/>
+                <a:cs typeface="Courier New" pitchFamily="34" charset="-120"/>
+              </a:rPr>
+              <a:t>⚡ QWATT</a:t>
+            </a:r>
+            <a:endParaRPr lang="en-US" sz="1000" dirty="0"/>
+          </a:p>
+        </p:txBody>
+      </p:sp>
+      <p:sp>
+        <p:nvSpPr>
+          <p:cNvPr id="3" name="Text"/>
+          <p:cNvSpPr/>
+          <p:nvPr/>
+        </p:nvSpPr>
+        <p:spPr>
+          <a:xfrm>
+            <a:off x="7525512" y="6473952"/>
+            <a:ext cx="4114800" cy="274320"/>
+          </a:xfrm>
+          <a:prstGeom prst="rect">
+            <a:avLst/>
+          </a:prstGeom>
+          <a:noFill/>
+          <a:ln/>
+        </p:spPr>
+        <p:txBody>
+          <a:bodyPr wrap="square" lIns="0" tIns="0" rIns="0" bIns="0" rtlCol="0" anchor="ctr"/>
+          <a:lstStyle/>
+          <a:p>
+            <a:pPr marL="0" indent="0" algn="r">
+              <a:buNone/>
+            </a:pPr>
+            <a:r>
+              <a:rPr lang="en-US" sz="900" dirty="0">
+                <a:solidFill>
+                  <a:srgbClr val="8B7A64"/>
+                </a:solidFill>
+                <a:latin typeface="Courier New" pitchFamily="34" charset="0"/>
+                <a:ea typeface="Courier New" pitchFamily="34" charset="-122"/>
+                <a:cs typeface="Courier New" pitchFamily="34" charset="-120"/>
+              </a:rPr>
+              <a:t>The Clean Token · qwatt.org</a:t>
+            </a:r>
+            <a:endParaRPr lang="en-US" sz="900" dirty="0"/>
+          </a:p>
+        </p:txBody>
+      </p:sp>
+      <p:sp>
+        <p:nvSpPr>
+          <p:cNvPr id="4" name="Text"/>
+          <p:cNvSpPr/>
+          <p:nvPr/>
+        </p:nvSpPr>
+        <p:spPr>
+          <a:xfrm>
+            <a:off x="548640" y="384048"/>
+            <a:ext cx="11091672" cy="274320"/>
+          </a:xfrm>
+          <a:prstGeom prst="rect">
+            <a:avLst/>
+          </a:prstGeom>
+          <a:noFill/>
+          <a:ln/>
+        </p:spPr>
+        <p:txBody>
+          <a:bodyPr wrap="square" lIns="0" tIns="0" rIns="0" bIns="0" rtlCol="0" anchor="ctr"/>
+          <a:lstStyle/>
+          <a:p>
+            <a:pPr marL="0" indent="0">
+              <a:buNone/>
+            </a:pPr>
+            <a:r>
+              <a:rPr lang="en-US" sz="1100" b="1" spc="300" kern="0" dirty="0">
+                <a:solidFill>
+                  <a:srgbClr val="D08A57"/>
+                </a:solidFill>
+                <a:latin typeface="Courier New" pitchFamily="34" charset="0"/>
+                <a:ea typeface="Courier New" pitchFamily="34" charset="-122"/>
+                <a:cs typeface="Courier New" pitchFamily="34" charset="-120"/>
+              </a:rPr>
+              <a:t>THE FIRST SPRINT — STELLAR INSTAWARDS</a:t>
+            </a:r>
+            <a:endParaRPr lang="en-US" sz="1100" dirty="0"/>
+          </a:p>
+        </p:txBody>
+      </p:sp>
+      <p:sp>
+        <p:nvSpPr>
+          <p:cNvPr id="5" name="Text"/>
+          <p:cNvSpPr/>
+          <p:nvPr/>
+        </p:nvSpPr>
+        <p:spPr>
+          <a:xfrm>
+            <a:off x="548640" y="658368"/>
+            <a:ext cx="11091672" cy="685800"/>
+          </a:xfrm>
+          <a:prstGeom prst="rect">
+            <a:avLst/>
+          </a:prstGeom>
+          <a:noFill/>
+          <a:ln/>
+        </p:spPr>
+        <p:txBody>
+          <a:bodyPr wrap="square" lIns="0" tIns="0" rIns="0" bIns="0" rtlCol="0" anchor="ctr"/>
+          <a:lstStyle/>
+          <a:p>
+            <a:pPr marL="0" indent="0">
+              <a:buNone/>
+            </a:pPr>
+            <a:r>
+              <a:rPr lang="en-US" sz="3000" b="1" dirty="0">
+                <a:solidFill>
+                  <a:srgbClr val="F0E8DC"/>
+                </a:solidFill>
+                <a:latin typeface="Arial" pitchFamily="34" charset="0"/>
+                <a:ea typeface="Arial" pitchFamily="34" charset="-122"/>
+                <a:cs typeface="Arial" pitchFamily="34" charset="-120"/>
+              </a:rPr>
+              <a:t>WattNode v0: the first real kWh on-chain</a:t>
+            </a:r>
+            <a:endParaRPr lang="en-US" sz="3000" dirty="0"/>
+          </a:p>
+        </p:txBody>
+      </p:sp>
+      <p:sp>
+        <p:nvSpPr>
+          <p:cNvPr id="6" name="Card"/>
+          <p:cNvSpPr/>
+          <p:nvPr/>
+        </p:nvSpPr>
+        <p:spPr>
+          <a:xfrm>
+            <a:off x="548640" y="1691640"/>
+            <a:ext cx="5362956" cy="1417320"/>
+          </a:xfrm>
+          <a:prstGeom prst="roundRect">
+            <a:avLst>
+              <a:gd name="adj" fmla="val 3871"/>
+            </a:avLst>
+          </a:prstGeom>
+          <a:solidFill>
+            <a:srgbClr val="231A10"/>
+          </a:solidFill>
+          <a:ln w="12700">
+            <a:solidFill>
+              <a:srgbClr val="3B2D1D"/>
+            </a:solidFill>
+            <a:prstDash val="solid"/>
+          </a:ln>
+        </p:spPr>
+      </p:sp>
+      <p:sp>
+        <p:nvSpPr>
+          <p:cNvPr id="7" name="Text"/>
+          <p:cNvSpPr/>
+          <p:nvPr/>
+        </p:nvSpPr>
+        <p:spPr>
+          <a:xfrm>
+            <a:off x="777240" y="1828800"/>
+            <a:ext cx="3717036" cy="320040"/>
+          </a:xfrm>
+          <a:prstGeom prst="rect">
+            <a:avLst/>
+          </a:prstGeom>
+          <a:noFill/>
+          <a:ln/>
+        </p:spPr>
+        <p:txBody>
+          <a:bodyPr wrap="square" lIns="0" tIns="0" rIns="0" bIns="0" rtlCol="0" anchor="ctr"/>
+          <a:lstStyle/>
+          <a:p>
+            <a:pPr marL="0" indent="0">
+              <a:buNone/>
+            </a:pPr>
+            <a:r>
+              <a:rPr lang="en-US" sz="1500" b="1" dirty="0">
+                <a:solidFill>
+                  <a:srgbClr val="F0E8DC"/>
+                </a:solidFill>
+                <a:latin typeface="Arial" pitchFamily="34" charset="0"/>
+                <a:ea typeface="Arial" pitchFamily="34" charset="-122"/>
+                <a:cs typeface="Arial" pitchFamily="34" charset="-120"/>
+              </a:rPr>
+              <a:t>P1 · First real PoG</a:t>
+            </a:r>
+            <a:endParaRPr lang="en-US" sz="1500" dirty="0"/>
+          </a:p>
+        </p:txBody>
+      </p:sp>
+      <p:sp>
+        <p:nvSpPr>
+          <p:cNvPr id="8" name="Chip"/>
+          <p:cNvSpPr/>
+          <p:nvPr/>
+        </p:nvSpPr>
+        <p:spPr>
+          <a:xfrm>
+            <a:off x="4585716" y="1856232"/>
+            <a:ext cx="1097280" cy="237744"/>
+          </a:xfrm>
+          <a:prstGeom prst="roundRect">
+            <a:avLst>
+              <a:gd name="adj" fmla="val 50000"/>
+            </a:avLst>
+          </a:prstGeom>
+          <a:solidFill>
+            <a:srgbClr val="16100A"/>
+          </a:solidFill>
+          <a:ln w="12700">
+            <a:solidFill>
+              <a:srgbClr val="D08A57"/>
+            </a:solidFill>
+            <a:prstDash val="solid"/>
+          </a:ln>
+        </p:spPr>
+      </p:sp>
+      <p:sp>
+        <p:nvSpPr>
+          <p:cNvPr id="9" name="Text"/>
+          <p:cNvSpPr/>
+          <p:nvPr/>
+        </p:nvSpPr>
+        <p:spPr>
+          <a:xfrm>
+            <a:off x="4585716" y="1848917"/>
+            <a:ext cx="1097280" cy="256032"/>
+          </a:xfrm>
+          <a:prstGeom prst="rect">
+            <a:avLst/>
+          </a:prstGeom>
+          <a:noFill/>
+          <a:ln/>
+        </p:spPr>
+        <p:txBody>
+          <a:bodyPr wrap="square" lIns="0" tIns="0" rIns="0" bIns="0" rtlCol="0" anchor="ctr"/>
+          <a:lstStyle/>
+          <a:p>
+            <a:pPr marL="0" indent="0" algn="ctr">
+              <a:buNone/>
+            </a:pPr>
+            <a:r>
+              <a:rPr lang="en-US" sz="850" b="1" dirty="0">
+                <a:solidFill>
+                  <a:srgbClr val="D08A57"/>
+                </a:solidFill>
+                <a:latin typeface="Courier New" pitchFamily="34" charset="0"/>
+                <a:ea typeface="Courier New" pitchFamily="34" charset="-122"/>
+                <a:cs typeface="Courier New" pitchFamily="34" charset="-120"/>
+              </a:rPr>
+              <a:t>WEEK 3</a:t>
+            </a:r>
+            <a:endParaRPr lang="en-US" sz="850" dirty="0"/>
+          </a:p>
+        </p:txBody>
+      </p:sp>
+      <p:sp>
+        <p:nvSpPr>
+          <p:cNvPr id="10" name="Text"/>
+          <p:cNvSpPr/>
+          <p:nvPr/>
+        </p:nvSpPr>
+        <p:spPr>
+          <a:xfrm>
+            <a:off x="777240" y="2221992"/>
+            <a:ext cx="4905756" cy="777240"/>
+          </a:xfrm>
+          <a:prstGeom prst="rect">
+            <a:avLst/>
+          </a:prstGeom>
+          <a:noFill/>
+          <a:ln/>
+        </p:spPr>
+        <p:txBody>
+          <a:bodyPr wrap="square" lIns="0" tIns="0" rIns="0" bIns="0" rtlCol="0" anchor="ctr"/>
+          <a:lstStyle/>
+          <a:p>
+            <a:pPr marL="0" indent="0">
+              <a:buNone/>
+            </a:pPr>
+            <a:r>
+              <a:rPr lang="en-US" sz="1150" dirty="0">
+                <a:solidFill>
+                  <a:srgbClr val="B3A48F"/>
+                </a:solidFill>
+                <a:latin typeface="Arial" pitchFamily="34" charset="0"/>
+                <a:ea typeface="Arial" pitchFamily="34" charset="-122"/>
+                <a:cs typeface="Arial" pitchFamily="34" charset="-120"/>
+              </a:rPr>
+              <a:t>Real meters (Modbus RTU + Shelly 3EM) → gateway → PoG memo → QW-000001 visible to anyone in the Explorer</a:t>
+            </a:r>
+            <a:endParaRPr lang="en-US" sz="1150" dirty="0"/>
+          </a:p>
+        </p:txBody>
+      </p:sp>
+      <p:sp>
+        <p:nvSpPr>
+          <p:cNvPr id="11" name="Card"/>
+          <p:cNvSpPr/>
+          <p:nvPr/>
+        </p:nvSpPr>
+        <p:spPr>
+          <a:xfrm>
+            <a:off x="6277356" y="1691640"/>
+            <a:ext cx="5362956" cy="1417320"/>
+          </a:xfrm>
+          <a:prstGeom prst="roundRect">
+            <a:avLst>
+              <a:gd name="adj" fmla="val 3871"/>
+            </a:avLst>
+          </a:prstGeom>
+          <a:solidFill>
+            <a:srgbClr val="231A10"/>
+          </a:solidFill>
+          <a:ln w="12700">
+            <a:solidFill>
+              <a:srgbClr val="3B2D1D"/>
+            </a:solidFill>
+            <a:prstDash val="solid"/>
+          </a:ln>
+        </p:spPr>
+      </p:sp>
+      <p:sp>
+        <p:nvSpPr>
+          <p:cNvPr id="12" name="Text"/>
+          <p:cNvSpPr/>
+          <p:nvPr/>
+        </p:nvSpPr>
+        <p:spPr>
+          <a:xfrm>
+            <a:off x="6505956" y="1828800"/>
+            <a:ext cx="3717036" cy="320040"/>
+          </a:xfrm>
+          <a:prstGeom prst="rect">
+            <a:avLst/>
+          </a:prstGeom>
+          <a:noFill/>
+          <a:ln/>
+        </p:spPr>
+        <p:txBody>
+          <a:bodyPr wrap="square" lIns="0" tIns="0" rIns="0" bIns="0" rtlCol="0" anchor="ctr"/>
+          <a:lstStyle/>
+          <a:p>
+            <a:pPr marL="0" indent="0">
+              <a:buNone/>
+            </a:pPr>
+            <a:r>
+              <a:rPr lang="en-US" sz="1500" b="1" dirty="0">
+                <a:solidFill>
+                  <a:srgbClr val="F0E8DC"/>
+                </a:solidFill>
+                <a:latin typeface="Arial" pitchFamily="34" charset="0"/>
+                <a:ea typeface="Arial" pitchFamily="34" charset="-122"/>
+                <a:cs typeface="Arial" pitchFamily="34" charset="-120"/>
+              </a:rPr>
+              <a:t>P2 · Node signing</a:t>
+            </a:r>
+            <a:endParaRPr lang="en-US" sz="1500" dirty="0"/>
+          </a:p>
+        </p:txBody>
+      </p:sp>
+      <p:sp>
+        <p:nvSpPr>
+          <p:cNvPr id="13" name="Chip"/>
+          <p:cNvSpPr/>
+          <p:nvPr/>
+        </p:nvSpPr>
+        <p:spPr>
+          <a:xfrm>
+            <a:off x="10314432" y="1856232"/>
+            <a:ext cx="1097280" cy="237744"/>
+          </a:xfrm>
+          <a:prstGeom prst="roundRect">
+            <a:avLst>
+              <a:gd name="adj" fmla="val 50000"/>
+            </a:avLst>
+          </a:prstGeom>
+          <a:solidFill>
+            <a:srgbClr val="16100A"/>
+          </a:solidFill>
+          <a:ln w="12700">
+            <a:solidFill>
+              <a:srgbClr val="D08A57"/>
+            </a:solidFill>
+            <a:prstDash val="solid"/>
+          </a:ln>
+        </p:spPr>
+      </p:sp>
+      <p:sp>
+        <p:nvSpPr>
+          <p:cNvPr id="14" name="Text"/>
+          <p:cNvSpPr/>
+          <p:nvPr/>
+        </p:nvSpPr>
+        <p:spPr>
+          <a:xfrm>
+            <a:off x="10314432" y="1848917"/>
+            <a:ext cx="1097280" cy="256032"/>
+          </a:xfrm>
+          <a:prstGeom prst="rect">
+            <a:avLst/>
+          </a:prstGeom>
+          <a:noFill/>
+          <a:ln/>
+        </p:spPr>
+        <p:txBody>
+          <a:bodyPr wrap="square" lIns="0" tIns="0" rIns="0" bIns="0" rtlCol="0" anchor="ctr"/>
+          <a:lstStyle/>
+          <a:p>
+            <a:pPr marL="0" indent="0" algn="ctr">
+              <a:buNone/>
+            </a:pPr>
+            <a:r>
+              <a:rPr lang="en-US" sz="850" b="1" dirty="0">
+                <a:solidFill>
+                  <a:srgbClr val="D08A57"/>
+                </a:solidFill>
+                <a:latin typeface="Courier New" pitchFamily="34" charset="0"/>
+                <a:ea typeface="Courier New" pitchFamily="34" charset="-122"/>
+                <a:cs typeface="Courier New" pitchFamily="34" charset="-120"/>
+              </a:rPr>
+              <a:t>WEEK 3</a:t>
+            </a:r>
+            <a:endParaRPr lang="en-US" sz="850" dirty="0"/>
+          </a:p>
+        </p:txBody>
+      </p:sp>
+      <p:sp>
+        <p:nvSpPr>
+          <p:cNvPr id="15" name="Text"/>
+          <p:cNvSpPr/>
+          <p:nvPr/>
+        </p:nvSpPr>
+        <p:spPr>
+          <a:xfrm>
+            <a:off x="6505956" y="2221992"/>
+            <a:ext cx="4905756" cy="777240"/>
+          </a:xfrm>
+          <a:prstGeom prst="rect">
+            <a:avLst/>
+          </a:prstGeom>
+          <a:noFill/>
+          <a:ln/>
+        </p:spPr>
+        <p:txBody>
+          <a:bodyPr wrap="square" lIns="0" tIns="0" rIns="0" bIns="0" rtlCol="0" anchor="ctr"/>
+          <a:lstStyle/>
+          <a:p>
+            <a:pPr marL="0" indent="0">
+              <a:buNone/>
+            </a:pPr>
+            <a:r>
+              <a:rPr lang="en-US" sz="1150" dirty="0">
+                <a:solidFill>
+                  <a:srgbClr val="B3A48F"/>
+                </a:solidFill>
+                <a:latin typeface="Arial" pitchFamily="34" charset="0"/>
+                <a:ea typeface="Arial" pitchFamily="34" charset="-122"/>
+                <a:cs typeface="Arial" pitchFamily="34" charset="-120"/>
+              </a:rPr>
+              <a:t>Panel key on the gateway; two-signature mint — a compromised node is a broken sensor, not a money printer</a:t>
+            </a:r>
+            <a:endParaRPr lang="en-US" sz="1150" dirty="0"/>
+          </a:p>
+        </p:txBody>
+      </p:sp>
+      <p:sp>
+        <p:nvSpPr>
+          <p:cNvPr id="16" name="Card"/>
+          <p:cNvSpPr/>
+          <p:nvPr/>
+        </p:nvSpPr>
+        <p:spPr>
+          <a:xfrm>
+            <a:off x="548640" y="3429000"/>
+            <a:ext cx="5362956" cy="1417320"/>
+          </a:xfrm>
+          <a:prstGeom prst="roundRect">
+            <a:avLst>
+              <a:gd name="adj" fmla="val 3871"/>
+            </a:avLst>
+          </a:prstGeom>
+          <a:solidFill>
+            <a:srgbClr val="231A10"/>
+          </a:solidFill>
+          <a:ln w="12700">
+            <a:solidFill>
+              <a:srgbClr val="3B2D1D"/>
+            </a:solidFill>
+            <a:prstDash val="solid"/>
+          </a:ln>
+        </p:spPr>
+      </p:sp>
+      <p:sp>
+        <p:nvSpPr>
+          <p:cNvPr id="17" name="Text"/>
+          <p:cNvSpPr/>
+          <p:nvPr/>
+        </p:nvSpPr>
+        <p:spPr>
+          <a:xfrm>
+            <a:off x="777240" y="3566160"/>
+            <a:ext cx="3717036" cy="320040"/>
+          </a:xfrm>
+          <a:prstGeom prst="rect">
+            <a:avLst/>
+          </a:prstGeom>
+          <a:noFill/>
+          <a:ln/>
+        </p:spPr>
+        <p:txBody>
+          <a:bodyPr wrap="square" lIns="0" tIns="0" rIns="0" bIns="0" rtlCol="0" anchor="ctr"/>
+          <a:lstStyle/>
+          <a:p>
+            <a:pPr marL="0" indent="0">
+              <a:buNone/>
+            </a:pPr>
+            <a:r>
+              <a:rPr lang="en-US" sz="1500" b="1" dirty="0">
+                <a:solidFill>
+                  <a:srgbClr val="F0E8DC"/>
+                </a:solidFill>
+                <a:latin typeface="Arial" pitchFamily="34" charset="0"/>
+                <a:ea typeface="Arial" pitchFamily="34" charset="-122"/>
+                <a:cs typeface="Arial" pitchFamily="34" charset="-120"/>
+              </a:rPr>
+              <a:t>P3 · Physical anti-fraud</a:t>
+            </a:r>
+            <a:endParaRPr lang="en-US" sz="1500" dirty="0"/>
+          </a:p>
+        </p:txBody>
+      </p:sp>
+      <p:sp>
+        <p:nvSpPr>
+          <p:cNvPr id="18" name="Chip"/>
+          <p:cNvSpPr/>
+          <p:nvPr/>
+        </p:nvSpPr>
+        <p:spPr>
+          <a:xfrm>
+            <a:off x="4585716" y="3593592"/>
+            <a:ext cx="1097280" cy="237744"/>
+          </a:xfrm>
+          <a:prstGeom prst="roundRect">
+            <a:avLst>
+              <a:gd name="adj" fmla="val 50000"/>
+            </a:avLst>
+          </a:prstGeom>
+          <a:solidFill>
+            <a:srgbClr val="16100A"/>
+          </a:solidFill>
+          <a:ln w="12700">
+            <a:solidFill>
+              <a:srgbClr val="D08A57"/>
+            </a:solidFill>
+            <a:prstDash val="solid"/>
+          </a:ln>
+        </p:spPr>
+      </p:sp>
+      <p:sp>
+        <p:nvSpPr>
+          <p:cNvPr id="19" name="Text"/>
+          <p:cNvSpPr/>
+          <p:nvPr/>
+        </p:nvSpPr>
+        <p:spPr>
+          <a:xfrm>
+            <a:off x="4585716" y="3586277"/>
+            <a:ext cx="1097280" cy="256032"/>
+          </a:xfrm>
+          <a:prstGeom prst="rect">
+            <a:avLst/>
+          </a:prstGeom>
+          <a:noFill/>
+          <a:ln/>
+        </p:spPr>
+        <p:txBody>
+          <a:bodyPr wrap="square" lIns="0" tIns="0" rIns="0" bIns="0" rtlCol="0" anchor="ctr"/>
+          <a:lstStyle/>
+          <a:p>
+            <a:pPr marL="0" indent="0" algn="ctr">
+              <a:buNone/>
+            </a:pPr>
+            <a:r>
+              <a:rPr lang="en-US" sz="850" b="1" dirty="0">
+                <a:solidFill>
+                  <a:srgbClr val="D08A57"/>
+                </a:solidFill>
+                <a:latin typeface="Courier New" pitchFamily="34" charset="0"/>
+                <a:ea typeface="Courier New" pitchFamily="34" charset="-122"/>
+                <a:cs typeface="Courier New" pitchFamily="34" charset="-120"/>
+              </a:rPr>
+              <a:t>WEEK 4</a:t>
+            </a:r>
+            <a:endParaRPr lang="en-US" sz="850" dirty="0"/>
+          </a:p>
+        </p:txBody>
+      </p:sp>
+      <p:sp>
+        <p:nvSpPr>
+          <p:cNvPr id="20" name="Text"/>
+          <p:cNvSpPr/>
+          <p:nvPr/>
+        </p:nvSpPr>
+        <p:spPr>
+          <a:xfrm>
+            <a:off x="777240" y="3959352"/>
+            <a:ext cx="4905756" cy="777240"/>
+          </a:xfrm>
+          <a:prstGeom prst="rect">
+            <a:avLst/>
+          </a:prstGeom>
+          <a:noFill/>
+          <a:ln/>
+        </p:spPr>
+        <p:txBody>
+          <a:bodyPr wrap="square" lIns="0" tIns="0" rIns="0" bIns="0" rtlCol="0" anchor="ctr"/>
+          <a:lstStyle/>
+          <a:p>
+            <a:pPr marL="0" indent="0">
+              <a:buNone/>
+            </a:pPr>
+            <a:r>
+              <a:rPr lang="en-US" sz="1150" dirty="0">
+                <a:solidFill>
+                  <a:srgbClr val="B3A48F"/>
+                </a:solidFill>
+                <a:latin typeface="Arial" pitchFamily="34" charset="0"/>
+                <a:ea typeface="Arial" pitchFamily="34" charset="-122"/>
+                <a:cs typeface="Arial" pitchFamily="34" charset="-120"/>
+              </a:rPr>
+              <a:t>Sun witness + validators: capacity cap, night generation, meter divergence, clock drift, tamper flags</a:t>
+            </a:r>
+            <a:endParaRPr lang="en-US" sz="1150" dirty="0"/>
+          </a:p>
+        </p:txBody>
+      </p:sp>
+      <p:sp>
+        <p:nvSpPr>
+          <p:cNvPr id="21" name="Card"/>
+          <p:cNvSpPr/>
+          <p:nvPr/>
+        </p:nvSpPr>
+        <p:spPr>
+          <a:xfrm>
+            <a:off x="6277356" y="3429000"/>
+            <a:ext cx="5362956" cy="1417320"/>
+          </a:xfrm>
+          <a:prstGeom prst="roundRect">
+            <a:avLst>
+              <a:gd name="adj" fmla="val 3871"/>
+            </a:avLst>
+          </a:prstGeom>
+          <a:solidFill>
+            <a:srgbClr val="231A10"/>
+          </a:solidFill>
+          <a:ln w="12700">
+            <a:solidFill>
+              <a:srgbClr val="3B2D1D"/>
+            </a:solidFill>
+            <a:prstDash val="solid"/>
+          </a:ln>
+        </p:spPr>
+      </p:sp>
+      <p:sp>
+        <p:nvSpPr>
+          <p:cNvPr id="22" name="Text"/>
+          <p:cNvSpPr/>
+          <p:nvPr/>
+        </p:nvSpPr>
+        <p:spPr>
+          <a:xfrm>
+            <a:off x="6505956" y="3566160"/>
+            <a:ext cx="3717036" cy="320040"/>
+          </a:xfrm>
+          <a:prstGeom prst="rect">
+            <a:avLst/>
+          </a:prstGeom>
+          <a:noFill/>
+          <a:ln/>
+        </p:spPr>
+        <p:txBody>
+          <a:bodyPr wrap="square" lIns="0" tIns="0" rIns="0" bIns="0" rtlCol="0" anchor="ctr"/>
+          <a:lstStyle/>
+          <a:p>
+            <a:pPr marL="0" indent="0">
+              <a:buNone/>
+            </a:pPr>
+            <a:r>
+              <a:rPr lang="en-US" sz="1500" b="1" dirty="0">
+                <a:solidFill>
+                  <a:srgbClr val="F0E8DC"/>
+                </a:solidFill>
+                <a:latin typeface="Arial" pitchFamily="34" charset="0"/>
+                <a:ea typeface="Arial" pitchFamily="34" charset="-122"/>
+                <a:cs typeface="Arial" pitchFamily="34" charset="-120"/>
+              </a:rPr>
+              <a:t>P4 · Public write-up</a:t>
+            </a:r>
+            <a:endParaRPr lang="en-US" sz="1500" dirty="0"/>
+          </a:p>
+        </p:txBody>
+      </p:sp>
+      <p:sp>
+        <p:nvSpPr>
+          <p:cNvPr id="23" name="Chip"/>
+          <p:cNvSpPr/>
+          <p:nvPr/>
+        </p:nvSpPr>
+        <p:spPr>
+          <a:xfrm>
+            <a:off x="10314432" y="3593592"/>
+            <a:ext cx="1097280" cy="237744"/>
+          </a:xfrm>
+          <a:prstGeom prst="roundRect">
+            <a:avLst>
+              <a:gd name="adj" fmla="val 50000"/>
+            </a:avLst>
+          </a:prstGeom>
+          <a:solidFill>
+            <a:srgbClr val="16100A"/>
+          </a:solidFill>
+          <a:ln w="12700">
+            <a:solidFill>
+              <a:srgbClr val="D08A57"/>
+            </a:solidFill>
+            <a:prstDash val="solid"/>
+          </a:ln>
+        </p:spPr>
+      </p:sp>
+      <p:sp>
+        <p:nvSpPr>
+          <p:cNvPr id="24" name="Text"/>
+          <p:cNvSpPr/>
+          <p:nvPr/>
+        </p:nvSpPr>
+        <p:spPr>
+          <a:xfrm>
+            <a:off x="10314432" y="3586277"/>
+            <a:ext cx="1097280" cy="256032"/>
+          </a:xfrm>
+          <a:prstGeom prst="rect">
+            <a:avLst/>
+          </a:prstGeom>
+          <a:noFill/>
+          <a:ln/>
+        </p:spPr>
+        <p:txBody>
+          <a:bodyPr wrap="square" lIns="0" tIns="0" rIns="0" bIns="0" rtlCol="0" anchor="ctr"/>
+          <a:lstStyle/>
+          <a:p>
+            <a:pPr marL="0" indent="0" algn="ctr">
+              <a:buNone/>
+            </a:pPr>
+            <a:r>
+              <a:rPr lang="en-US" sz="850" b="1" dirty="0">
+                <a:solidFill>
+                  <a:srgbClr val="D08A57"/>
+                </a:solidFill>
+                <a:latin typeface="Courier New" pitchFamily="34" charset="0"/>
+                <a:ea typeface="Courier New" pitchFamily="34" charset="-122"/>
+                <a:cs typeface="Courier New" pitchFamily="34" charset="-120"/>
+              </a:rPr>
+              <a:t>WEEK 4</a:t>
+            </a:r>
+            <a:endParaRPr lang="en-US" sz="850" dirty="0"/>
+          </a:p>
+        </p:txBody>
+      </p:sp>
+      <p:sp>
+        <p:nvSpPr>
+          <p:cNvPr id="25" name="Text"/>
+          <p:cNvSpPr/>
+          <p:nvPr/>
+        </p:nvSpPr>
+        <p:spPr>
+          <a:xfrm>
+            <a:off x="6505956" y="3959352"/>
+            <a:ext cx="4905756" cy="777240"/>
+          </a:xfrm>
+          <a:prstGeom prst="rect">
+            <a:avLst/>
+          </a:prstGeom>
+          <a:noFill/>
+          <a:ln/>
+        </p:spPr>
+        <p:txBody>
+          <a:bodyPr wrap="square" lIns="0" tIns="0" rIns="0" bIns="0" rtlCol="0" anchor="ctr"/>
+          <a:lstStyle/>
+          <a:p>
+            <a:pPr marL="0" indent="0">
+              <a:buNone/>
+            </a:pPr>
+            <a:r>
+              <a:rPr lang="en-US" sz="1150" dirty="0">
+                <a:solidFill>
+                  <a:srgbClr val="B3A48F"/>
+                </a:solidFill>
+                <a:latin typeface="Arial" pitchFamily="34" charset="0"/>
+                <a:ea typeface="Arial" pitchFamily="34" charset="-122"/>
+                <a:cs typeface="Arial" pitchFamily="34" charset="-120"/>
+              </a:rPr>
+              <a:t>Bilingual write-up + demo video + code on GitHub — presented live at Stellar Barrio</a:t>
+            </a:r>
+            <a:endParaRPr lang="en-US" sz="1150" dirty="0"/>
+          </a:p>
+        </p:txBody>
+      </p:sp>
+      <p:sp>
+        <p:nvSpPr>
+          <p:cNvPr id="26" name="Text"/>
+          <p:cNvSpPr/>
+          <p:nvPr/>
+        </p:nvSpPr>
+        <p:spPr>
+          <a:xfrm>
+            <a:off x="548640" y="5349240"/>
+            <a:ext cx="11091672" cy="274320"/>
+          </a:xfrm>
+          <a:prstGeom prst="rect">
+            <a:avLst/>
+          </a:prstGeom>
+          <a:noFill/>
+          <a:ln/>
+        </p:spPr>
+        <p:txBody>
+          <a:bodyPr wrap="square" lIns="0" tIns="0" rIns="0" bIns="0" rtlCol="0" anchor="ctr"/>
+          <a:lstStyle/>
+          <a:p>
+            <a:pPr marL="0" indent="0" algn="ctr">
+              <a:buNone/>
+            </a:pPr>
+            <a:r>
+              <a:rPr lang="en-US" sz="1250" dirty="0">
+                <a:solidFill>
+                  <a:srgbClr val="D9B26A"/>
+                </a:solidFill>
+                <a:latin typeface="Arial" pitchFamily="34" charset="0"/>
+                <a:ea typeface="Arial" pitchFamily="34" charset="-122"/>
+                <a:cs typeface="Arial" pitchFamily="34" charset="-120"/>
+              </a:rPr>
+              <a:t>Ask: ≈ $900 USD in verification hardware · the solar system already exists · labor contributed by the team.</a:t>
+            </a:r>
+            <a:endParaRPr lang="en-US" sz="1250" dirty="0"/>
           </a:p>
         </p:txBody>
       </p:sp>

</xml_diff>